<commit_message>
fix(presentation & telemetry): embed submission visuals into slides, fix FPS reporting calculation and eliminate layout collisions
</commit_message>
<xml_diff>
--- a/Phoenix_X_SIH26169_Final.pptx
+++ b/Phoenix_X_SIH26169_Final.pptx
@@ -5501,35 +5501,6 @@
       </p:sp>
       <p:pic>
         <p:nvPicPr>
-          <p:cNvPr id="5" name="Picture 4" descr="Smart India Hackathon 2026 light-bulb logo">
-            <a:extLst>
-              <a:ext uri="{FF2B5EF4-FFF2-40B4-BE49-F238E27FC236}">
-                <a16:creationId xmlns:a16="http://schemas.microsoft.com/office/drawing/2014/main" id="{9120848B-B2B4-45BE-A961-AEC0B06CF41B}"/>
-              </a:ext>
-            </a:extLst>
-          </p:cNvPr>
-          <p:cNvPicPr>
-            <a:picLocks noChangeAspect="1"/>
-          </p:cNvPicPr>
-          <p:nvPr/>
-        </p:nvPicPr>
-        <p:blipFill rotWithShape="1">
-          <a:blip r:embed="rId3"/>
-          <a:srcRect r="59916"/>
-          <a:stretch/>
-        </p:blipFill>
-        <p:spPr>
-          <a:xfrm>
-            <a:off x="9331575" y="1392300"/>
-            <a:ext cx="1601754" cy="1713118"/>
-          </a:xfrm>
-          <a:prstGeom prst="rect">
-            <a:avLst/>
-          </a:prstGeom>
-        </p:spPr>
-      </p:pic>
-      <p:pic>
-        <p:nvPicPr>
           <p:cNvPr id="2" name="Picture 1"/>
           <p:cNvPicPr>
             <a:picLocks noChangeAspect="1"/>
@@ -6941,6 +6912,30 @@
           </a:p>
         </p:txBody>
       </p:sp>
+      <p:pic>
+        <p:nvPicPr>
+          <p:cNvPr id="75" name="Picture 74" descr="01_satellite_ground_laser_link.jpg"/>
+          <p:cNvPicPr>
+            <a:picLocks noChangeAspect="1"/>
+          </p:cNvPicPr>
+          <p:nvPr/>
+        </p:nvPicPr>
+        <p:blipFill>
+          <a:blip r:embed="rId5"/>
+          <a:stretch>
+            <a:fillRect/>
+          </a:stretch>
+        </p:blipFill>
+        <p:spPr>
+          <a:xfrm>
+            <a:off x="8092440" y="1188720"/>
+            <a:ext cx="3611880" cy="2240280"/>
+          </a:xfrm>
+          <a:prstGeom prst="rect">
+            <a:avLst/>
+          </a:prstGeom>
+        </p:spPr>
+      </p:pic>
     </p:spTree>
   </p:cSld>
   <p:clrMapOvr>
@@ -10039,38 +10034,6 @@
       </p:sp>
       <p:sp>
         <p:nvSpPr>
-          <p:cNvPr id="6" name="Slide Number Placeholder 5"/>
-          <p:cNvSpPr>
-            <a:spLocks noGrp="1"/>
-          </p:cNvSpPr>
-          <p:nvPr>
-            <p:ph type="sldNum" sz="quarter" idx="12"/>
-          </p:nvPr>
-        </p:nvSpPr>
-        <p:spPr/>
-        <p:txBody>
-          <a:bodyPr/>
-          <a:lstStyle/>
-          <a:p>
-            <a:fld id="{677C3CE7-23F7-4828-823C-E0205DF2CF97}" type="slidenum">
-              <a:rPr lang="en-US" b="1">
-                <a:solidFill>
-                  <a:schemeClr val="bg1"/>
-                </a:solidFill>
-              </a:rPr>
-              <a:pPr/>
-              <a:t>3</a:t>
-            </a:fld>
-            <a:endParaRPr lang="en-US" b="1" dirty="0">
-              <a:solidFill>
-                <a:schemeClr val="bg1"/>
-              </a:solidFill>
-            </a:endParaRPr>
-          </a:p>
-        </p:txBody>
-      </p:sp>
-      <p:sp>
-        <p:nvSpPr>
           <p:cNvPr id="7" name="Footer Placeholder 6"/>
           <p:cNvSpPr>
             <a:spLocks noGrp="1"/>
@@ -11509,49 +11472,30 @@
           </a:p>
         </p:txBody>
       </p:sp>
-      <p:sp>
-        <p:nvSpPr>
-          <p:cNvPr id="17447" name="TextBox 17446"/>
-          <p:cNvSpPr txBox="1"/>
-          <p:nvPr/>
-        </p:nvSpPr>
-        <p:spPr>
-          <a:xfrm>
-            <a:off x="6373368" y="1837943"/>
-            <a:ext cx="1600200" cy="352958"/>
-          </a:xfrm>
-          <a:prstGeom prst="rect">
-            <a:avLst/>
-          </a:prstGeom>
-          <a:noFill/>
-        </p:spPr>
-        <p:txBody>
-          <a:bodyPr wrap="square" lIns="0" rIns="0" tIns="0" bIns="0" anchor="ctr">
-            <a:noAutofit/>
-          </a:bodyPr>
-          <a:lstStyle/>
-          <a:p>
-            <a:pPr algn="l" marL="0" indent="0">
-              <a:spcBef>
-                <a:spcPts val="0"/>
-              </a:spcBef>
-              <a:spcAft>
-                <a:spcPts val="0"/>
-              </a:spcAft>
-              <a:buNone/>
-            </a:pPr>
-            <a:r>
-              <a:rPr sz="980" b="1" i="0" lang="en-US">
-                <a:solidFill>
-                  <a:srgbClr val="14345C"/>
-                </a:solidFill>
-                <a:latin typeface="Calibri"/>
-              </a:rPr>
-              <a:t>Core Architecture</a:t>
-            </a:r>
-          </a:p>
-        </p:txBody>
-      </p:sp>
+      <p:pic>
+        <p:nvPicPr>
+          <p:cNvPr id="17447" name="Picture 17446" descr="05_distributed_3node_architecture.png"/>
+          <p:cNvPicPr>
+            <a:picLocks noChangeAspect="1"/>
+          </p:cNvPicPr>
+          <p:nvPr/>
+        </p:nvPicPr>
+        <p:blipFill>
+          <a:blip r:embed="rId4"/>
+          <a:stretch>
+            <a:fillRect/>
+          </a:stretch>
+        </p:blipFill>
+        <p:spPr>
+          <a:xfrm>
+            <a:off x="6309360" y="1828800"/>
+            <a:ext cx="5193792" cy="2286000"/>
+          </a:xfrm>
+          <a:prstGeom prst="rect">
+            <a:avLst/>
+          </a:prstGeom>
+        </p:spPr>
+      </p:pic>
       <p:sp>
         <p:nvSpPr>
           <p:cNvPr id="17448" name="TextBox 17447"/>
@@ -11560,62 +11504,68 @@
         </p:nvSpPr>
         <p:spPr>
           <a:xfrm>
-            <a:off x="8001000" y="1837943"/>
-            <a:ext cx="3422599" cy="352958"/>
-          </a:xfrm>
-          <a:prstGeom prst="rect">
-            <a:avLst/>
-          </a:prstGeom>
-          <a:noFill/>
-        </p:spPr>
-        <p:txBody>
-          <a:bodyPr wrap="square" lIns="0" rIns="0" tIns="0" bIns="0" anchor="ctr">
-            <a:noAutofit/>
+            <a:off x="6309360" y="4251960"/>
+            <a:ext cx="1554480" cy="365760"/>
+          </a:xfrm>
+          <a:prstGeom prst="rect">
+            <a:avLst/>
+          </a:prstGeom>
+          <a:noFill/>
+        </p:spPr>
+        <p:txBody>
+          <a:bodyPr wrap="square">
+            <a:spAutoFit/>
           </a:bodyPr>
           <a:lstStyle/>
           <a:p>
-            <a:pPr algn="l" marL="0" indent="0">
-              <a:spcBef>
-                <a:spcPts val="0"/>
-              </a:spcBef>
-              <a:spcAft>
-                <a:spcPts val="0"/>
-              </a:spcAft>
-              <a:buNone/>
-            </a:pPr>
-            <a:r>
-              <a:rPr sz="940" b="0" i="0" lang="en-US">
-                <a:solidFill>
-                  <a:srgbClr val="1E2638"/>
-                </a:solidFill>
-                <a:latin typeface="Calibri"/>
-              </a:rPr>
-              <a:t>Python 3.11+ Native — high-IPC execution on ARM64 Apple Silicon &amp; x86_64 Windows</a:t>
-            </a:r>
-          </a:p>
-        </p:txBody>
-      </p:sp>
-      <p:cxnSp>
-        <p:nvCxnSpPr>
-          <p:cNvPr id="17449" name="Connector 17448"/>
-          <p:cNvCxnSpPr/>
-          <p:nvPr/>
-        </p:nvCxnSpPr>
-        <p:spPr>
-          <a:xfrm>
-            <a:off x="6373368" y="2200046"/>
-            <a:ext cx="5068519" cy="0"/>
-          </a:xfrm>
-          <a:prstGeom prst="line">
-            <a:avLst/>
-          </a:prstGeom>
-          <a:ln w="9525">
-            <a:solidFill>
-              <a:srgbClr val="D9E2EE"/>
-            </a:solidFill>
-          </a:ln>
-        </p:spPr>
-      </p:cxnSp>
+            <a:pPr>
+              <a:defRPr sz="850" b="1">
+                <a:solidFill>
+                  <a:srgbClr val="0F2240"/>
+                </a:solidFill>
+              </a:defRPr>
+            </a:pPr>
+            <a:r>
+              <a:t>IMM Kinematics</a:t>
+            </a:r>
+          </a:p>
+        </p:txBody>
+      </p:sp>
+      <p:sp>
+        <p:nvSpPr>
+          <p:cNvPr id="17449" name="TextBox 17448"/>
+          <p:cNvSpPr txBox="1"/>
+          <p:nvPr/>
+        </p:nvSpPr>
+        <p:spPr>
+          <a:xfrm>
+            <a:off x="7909560" y="4251960"/>
+            <a:ext cx="3593592" cy="411480"/>
+          </a:xfrm>
+          <a:prstGeom prst="rect">
+            <a:avLst/>
+          </a:prstGeom>
+          <a:noFill/>
+        </p:spPr>
+        <p:txBody>
+          <a:bodyPr wrap="square">
+            <a:spAutoFit/>
+          </a:bodyPr>
+          <a:lstStyle/>
+          <a:p>
+            <a:pPr>
+              <a:defRPr sz="800">
+                <a:solidFill>
+                  <a:srgbClr val="3C3C3C"/>
+                </a:solidFill>
+              </a:defRPr>
+            </a:pPr>
+            <a:r>
+              <a:t>Dual-mode Kalman filter combining CV and CT models to eliminate lag</a:t>
+            </a:r>
+          </a:p>
+        </p:txBody>
+      </p:sp>
       <p:sp>
         <p:nvSpPr>
           <p:cNvPr id="17450" name="TextBox 17449"/>
@@ -11624,37 +11574,29 @@
         </p:nvSpPr>
         <p:spPr>
           <a:xfrm>
-            <a:off x="6373368" y="2218334"/>
-            <a:ext cx="1600200" cy="352958"/>
-          </a:xfrm>
-          <a:prstGeom prst="rect">
-            <a:avLst/>
-          </a:prstGeom>
-          <a:noFill/>
-        </p:spPr>
-        <p:txBody>
-          <a:bodyPr wrap="square" lIns="0" rIns="0" tIns="0" bIns="0" anchor="ctr">
-            <a:noAutofit/>
+            <a:off x="6309360" y="4754880"/>
+            <a:ext cx="1554480" cy="365760"/>
+          </a:xfrm>
+          <a:prstGeom prst="rect">
+            <a:avLst/>
+          </a:prstGeom>
+          <a:noFill/>
+        </p:spPr>
+        <p:txBody>
+          <a:bodyPr wrap="square">
+            <a:spAutoFit/>
           </a:bodyPr>
           <a:lstStyle/>
           <a:p>
-            <a:pPr algn="l" marL="0" indent="0">
-              <a:spcBef>
-                <a:spcPts val="0"/>
-              </a:spcBef>
-              <a:spcAft>
-                <a:spcPts val="0"/>
-              </a:spcAft>
-              <a:buNone/>
-            </a:pPr>
-            <a:r>
-              <a:rPr sz="980" b="1" i="0" lang="en-US">
-                <a:solidFill>
-                  <a:srgbClr val="14345C"/>
-                </a:solidFill>
-                <a:latin typeface="Calibri"/>
-              </a:rPr>
-              <a:t>Simulation Engine</a:t>
+            <a:pPr>
+              <a:defRPr sz="850" b="1">
+                <a:solidFill>
+                  <a:srgbClr val="0F2240"/>
+                </a:solidFill>
+              </a:defRPr>
+            </a:pPr>
+            <a:r>
+              <a:t>Servo Control Loop</a:t>
             </a:r>
           </a:p>
         </p:txBody>
@@ -11667,37 +11609,29 @@
         </p:nvSpPr>
         <p:spPr>
           <a:xfrm>
-            <a:off x="8001000" y="2218334"/>
-            <a:ext cx="3422599" cy="352958"/>
-          </a:xfrm>
-          <a:prstGeom prst="rect">
-            <a:avLst/>
-          </a:prstGeom>
-          <a:noFill/>
-        </p:spPr>
-        <p:txBody>
-          <a:bodyPr wrap="square" lIns="0" rIns="0" tIns="0" bIns="0" anchor="ctr">
-            <a:noAutofit/>
+            <a:off x="7909560" y="4754880"/>
+            <a:ext cx="3593592" cy="411480"/>
+          </a:xfrm>
+          <a:prstGeom prst="rect">
+            <a:avLst/>
+          </a:prstGeom>
+          <a:noFill/>
+        </p:spPr>
+        <p:txBody>
+          <a:bodyPr wrap="square">
+            <a:spAutoFit/>
           </a:bodyPr>
           <a:lstStyle/>
           <a:p>
-            <a:pPr algn="l" marL="0" indent="0">
-              <a:spcBef>
-                <a:spcPts val="0"/>
-              </a:spcBef>
-              <a:spcAft>
-                <a:spcPts val="0"/>
-              </a:spcAft>
-              <a:buNone/>
-            </a:pPr>
-            <a:r>
-              <a:rPr sz="940" b="0" i="0" lang="en-US">
-                <a:solidFill>
-                  <a:srgbClr val="1E2638"/>
-                </a:solidFill>
-                <a:latin typeface="Calibri"/>
-              </a:rPr>
-              <a:t>NumPy — vectorized coordinate transformations &amp; multi-harmonic platform vibration arrays</a:t>
+            <a:pPr>
+              <a:defRPr sz="800">
+                <a:solidFill>
+                  <a:srgbClr val="3C3C3C"/>
+                </a:solidFill>
+              </a:defRPr>
+            </a:pPr>
+            <a:r>
+              <a:t>Feedforward predictive anti-windup PID (strict 5-10°/s slew clamping)</a:t>
             </a:r>
           </a:p>
         </p:txBody>
@@ -11710,18 +11644,27 @@
         </p:nvCxnSpPr>
         <p:spPr>
           <a:xfrm>
-            <a:off x="6373368" y="2580436"/>
-            <a:ext cx="5068519" cy="0"/>
+            <a:off x="6309360" y="4700016"/>
+            <a:ext cx="5193792" cy="0"/>
           </a:xfrm>
           <a:prstGeom prst="line">
             <a:avLst/>
           </a:prstGeom>
-          <a:ln w="9525">
-            <a:solidFill>
-              <a:srgbClr val="D9E2EE"/>
-            </a:solidFill>
-          </a:ln>
-        </p:spPr>
+        </p:spPr>
+        <p:style>
+          <a:lnRef idx="2">
+            <a:schemeClr val="accent1"/>
+          </a:lnRef>
+          <a:fillRef idx="0">
+            <a:schemeClr val="accent1"/>
+          </a:fillRef>
+          <a:effectRef idx="1">
+            <a:schemeClr val="accent1"/>
+          </a:effectRef>
+          <a:fontRef idx="minor">
+            <a:schemeClr val="tx1"/>
+          </a:fontRef>
+        </p:style>
       </p:cxnSp>
       <p:sp>
         <p:nvSpPr>
@@ -11731,37 +11674,29 @@
         </p:nvSpPr>
         <p:spPr>
           <a:xfrm>
-            <a:off x="6373368" y="2598724"/>
-            <a:ext cx="1600200" cy="352958"/>
-          </a:xfrm>
-          <a:prstGeom prst="rect">
-            <a:avLst/>
-          </a:prstGeom>
-          <a:noFill/>
-        </p:spPr>
-        <p:txBody>
-          <a:bodyPr wrap="square" lIns="0" rIns="0" tIns="0" bIns="0" anchor="ctr">
-            <a:noAutofit/>
+            <a:off x="6309360" y="5257800"/>
+            <a:ext cx="1554480" cy="365760"/>
+          </a:xfrm>
+          <a:prstGeom prst="rect">
+            <a:avLst/>
+          </a:prstGeom>
+          <a:noFill/>
+        </p:spPr>
+        <p:txBody>
+          <a:bodyPr wrap="square">
+            <a:spAutoFit/>
           </a:bodyPr>
           <a:lstStyle/>
           <a:p>
-            <a:pPr algn="l" marL="0" indent="0">
-              <a:spcBef>
-                <a:spcPts val="0"/>
-              </a:spcBef>
-              <a:spcAft>
-                <a:spcPts val="0"/>
-              </a:spcAft>
-              <a:buNone/>
-            </a:pPr>
-            <a:r>
-              <a:rPr sz="980" b="1" i="0" lang="en-US">
-                <a:solidFill>
-                  <a:srgbClr val="14345C"/>
-                </a:solidFill>
-                <a:latin typeface="Calibri"/>
-              </a:rPr>
-              <a:t>Optical Physics</a:t>
+            <a:pPr>
+              <a:defRPr sz="850" b="1">
+                <a:solidFill>
+                  <a:srgbClr val="0F2240"/>
+                </a:solidFill>
+              </a:defRPr>
+            </a:pPr>
+            <a:r>
+              <a:t>Tactical Cockpit GUI</a:t>
             </a:r>
           </a:p>
         </p:txBody>
@@ -11774,37 +11709,29 @@
         </p:nvSpPr>
         <p:spPr>
           <a:xfrm>
-            <a:off x="8001000" y="2598724"/>
-            <a:ext cx="3422599" cy="352958"/>
-          </a:xfrm>
-          <a:prstGeom prst="rect">
-            <a:avLst/>
-          </a:prstGeom>
-          <a:noFill/>
-        </p:spPr>
-        <p:txBody>
-          <a:bodyPr wrap="square" lIns="0" rIns="0" tIns="0" bIns="0" anchor="ctr">
-            <a:noAutofit/>
+            <a:off x="7909560" y="5257800"/>
+            <a:ext cx="3593592" cy="411480"/>
+          </a:xfrm>
+          <a:prstGeom prst="rect">
+            <a:avLst/>
+          </a:prstGeom>
+          <a:noFill/>
+        </p:spPr>
+        <p:txBody>
+          <a:bodyPr wrap="square">
+            <a:spAutoFit/>
           </a:bodyPr>
           <a:lstStyle/>
           <a:p>
-            <a:pPr algn="l" marL="0" indent="0">
-              <a:spcBef>
-                <a:spcPts val="0"/>
-              </a:spcBef>
-              <a:spcAft>
-                <a:spcPts val="0"/>
-              </a:spcAft>
-              <a:buNone/>
-            </a:pPr>
-            <a:r>
-              <a:rPr sz="940" b="0" i="0" lang="en-US">
-                <a:solidFill>
-                  <a:srgbClr val="1E2638"/>
-                </a:solidFill>
-                <a:latin typeface="Calibri"/>
-              </a:rPr>
-              <a:t>OpenCV &amp; SciPy — Airy disc diffraction convolution, Poisson noise, Beer-Lambert attenuation</a:t>
+            <a:pPr>
+              <a:defRPr sz="800">
+                <a:solidFill>
+                  <a:srgbClr val="3C3C3C"/>
+                </a:solidFill>
+              </a:defRPr>
+            </a:pPr>
+            <a:r>
+              <a:t>OpenCV Tactical HUD &amp; Live Web Radar (HTTP 8080) with manual PTZ override</a:t>
             </a:r>
           </a:p>
         </p:txBody>
@@ -11817,18 +11744,27 @@
         </p:nvCxnSpPr>
         <p:spPr>
           <a:xfrm>
-            <a:off x="6373368" y="2960827"/>
-            <a:ext cx="5068519" cy="0"/>
+            <a:off x="6309360" y="5202936"/>
+            <a:ext cx="5193792" cy="0"/>
           </a:xfrm>
           <a:prstGeom prst="line">
             <a:avLst/>
           </a:prstGeom>
-          <a:ln w="9525">
-            <a:solidFill>
-              <a:srgbClr val="D9E2EE"/>
-            </a:solidFill>
-          </a:ln>
-        </p:spPr>
+        </p:spPr>
+        <p:style>
+          <a:lnRef idx="2">
+            <a:schemeClr val="accent1"/>
+          </a:lnRef>
+          <a:fillRef idx="0">
+            <a:schemeClr val="accent1"/>
+          </a:fillRef>
+          <a:effectRef idx="1">
+            <a:schemeClr val="accent1"/>
+          </a:effectRef>
+          <a:fontRef idx="minor">
+            <a:schemeClr val="tx1"/>
+          </a:fontRef>
+        </p:style>
       </p:cxnSp>
       <p:sp>
         <p:nvSpPr>
@@ -11838,37 +11774,29 @@
         </p:nvSpPr>
         <p:spPr>
           <a:xfrm>
-            <a:off x="6373368" y="2979115"/>
-            <a:ext cx="1600200" cy="352958"/>
-          </a:xfrm>
-          <a:prstGeom prst="rect">
-            <a:avLst/>
-          </a:prstGeom>
-          <a:noFill/>
-        </p:spPr>
-        <p:txBody>
-          <a:bodyPr wrap="square" lIns="0" rIns="0" tIns="0" bIns="0" anchor="ctr">
-            <a:noAutofit/>
+            <a:off x="6309360" y="5760720"/>
+            <a:ext cx="1554480" cy="365760"/>
+          </a:xfrm>
+          <a:prstGeom prst="rect">
+            <a:avLst/>
+          </a:prstGeom>
+          <a:noFill/>
+        </p:spPr>
+        <p:txBody>
+          <a:bodyPr wrap="square">
+            <a:spAutoFit/>
           </a:bodyPr>
           <a:lstStyle/>
           <a:p>
-            <a:pPr algn="l" marL="0" indent="0">
-              <a:spcBef>
-                <a:spcPts val="0"/>
-              </a:spcBef>
-              <a:spcAft>
-                <a:spcPts val="0"/>
-              </a:spcAft>
-              <a:buNone/>
-            </a:pPr>
-            <a:r>
-              <a:rPr sz="980" b="1" i="0" lang="en-US">
-                <a:solidFill>
-                  <a:srgbClr val="14345C"/>
-                </a:solidFill>
-                <a:latin typeface="Calibri"/>
-              </a:rPr>
-              <a:t>Noise Suppression</a:t>
+            <a:pPr>
+              <a:defRPr sz="850" b="1">
+                <a:solidFill>
+                  <a:srgbClr val="0F2240"/>
+                </a:solidFill>
+              </a:defRPr>
+            </a:pPr>
+            <a:r>
+              <a:t>Compliance &amp; CI</a:t>
             </a:r>
           </a:p>
         </p:txBody>
@@ -11881,37 +11809,29 @@
         </p:nvSpPr>
         <p:spPr>
           <a:xfrm>
-            <a:off x="8001000" y="2979115"/>
-            <a:ext cx="3422599" cy="352958"/>
-          </a:xfrm>
-          <a:prstGeom prst="rect">
-            <a:avLst/>
-          </a:prstGeom>
-          <a:noFill/>
-        </p:spPr>
-        <p:txBody>
-          <a:bodyPr wrap="square" lIns="0" rIns="0" tIns="0" bIns="0" anchor="ctr">
-            <a:noAutofit/>
+            <a:off x="7909560" y="5760720"/>
+            <a:ext cx="3593592" cy="411480"/>
+          </a:xfrm>
+          <a:prstGeom prst="rect">
+            <a:avLst/>
+          </a:prstGeom>
+          <a:noFill/>
+        </p:spPr>
+        <p:txBody>
+          <a:bodyPr wrap="square">
+            <a:spAutoFit/>
           </a:bodyPr>
           <a:lstStyle/>
           <a:p>
-            <a:pPr algn="l" marL="0" indent="0">
-              <a:spcBef>
-                <a:spcPts val="0"/>
-              </a:spcBef>
-              <a:spcAft>
-                <a:spcPts val="0"/>
-              </a:spcAft>
-              <a:buNone/>
-            </a:pPr>
-            <a:r>
-              <a:rPr sz="940" b="0" i="0" lang="en-US">
-                <a:solidFill>
-                  <a:srgbClr val="1E2638"/>
-                </a:solidFill>
-                <a:latin typeface="Calibri"/>
-              </a:rPr>
-              <a:t>SIMD-accelerated median rank filtering (100% rejection of 10% S&amp;P noise in 0.8 ms)</a:t>
+            <a:pPr>
+              <a:defRPr sz="800">
+                <a:solidFill>
+                  <a:srgbClr val="3C3C3C"/>
+                </a:solidFill>
+              </a:defRPr>
+            </a:pPr>
+            <a:r>
+              <a:t>Automated CSV/PDF Benchmark-2 audit engine logging RMSE &amp; lock retention</a:t>
             </a:r>
           </a:p>
         </p:txBody>
@@ -11924,741 +11844,28 @@
         </p:nvCxnSpPr>
         <p:spPr>
           <a:xfrm>
-            <a:off x="6373368" y="3341217"/>
-            <a:ext cx="5068519" cy="0"/>
+            <a:off x="6309360" y="5705856"/>
+            <a:ext cx="5193792" cy="0"/>
           </a:xfrm>
           <a:prstGeom prst="line">
             <a:avLst/>
           </a:prstGeom>
-          <a:ln w="9525">
-            <a:solidFill>
-              <a:srgbClr val="D9E2EE"/>
-            </a:solidFill>
-          </a:ln>
-        </p:spPr>
+        </p:spPr>
+        <p:style>
+          <a:lnRef idx="2">
+            <a:schemeClr val="accent1"/>
+          </a:lnRef>
+          <a:fillRef idx="0">
+            <a:schemeClr val="accent1"/>
+          </a:fillRef>
+          <a:effectRef idx="1">
+            <a:schemeClr val="accent1"/>
+          </a:effectRef>
+          <a:fontRef idx="minor">
+            <a:schemeClr val="tx1"/>
+          </a:fontRef>
+        </p:style>
       </p:cxnSp>
-      <p:sp>
-        <p:nvSpPr>
-          <p:cNvPr id="17459" name="TextBox 17458"/>
-          <p:cNvSpPr txBox="1"/>
-          <p:nvPr/>
-        </p:nvSpPr>
-        <p:spPr>
-          <a:xfrm>
-            <a:off x="6373368" y="3359505"/>
-            <a:ext cx="1600200" cy="352958"/>
-          </a:xfrm>
-          <a:prstGeom prst="rect">
-            <a:avLst/>
-          </a:prstGeom>
-          <a:noFill/>
-        </p:spPr>
-        <p:txBody>
-          <a:bodyPr wrap="square" lIns="0" rIns="0" tIns="0" bIns="0" anchor="ctr">
-            <a:noAutofit/>
-          </a:bodyPr>
-          <a:lstStyle/>
-          <a:p>
-            <a:pPr algn="l" marL="0" indent="0">
-              <a:spcBef>
-                <a:spcPts val="0"/>
-              </a:spcBef>
-              <a:spcAft>
-                <a:spcPts val="0"/>
-              </a:spcAft>
-              <a:buNone/>
-            </a:pPr>
-            <a:r>
-              <a:rPr sz="980" b="1" i="0" lang="en-US">
-                <a:solidFill>
-                  <a:srgbClr val="14345C"/>
-                </a:solidFill>
-                <a:latin typeface="Calibri"/>
-              </a:rPr>
-              <a:t>Edge AI Perception</a:t>
-            </a:r>
-          </a:p>
-        </p:txBody>
-      </p:sp>
-      <p:sp>
-        <p:nvSpPr>
-          <p:cNvPr id="17460" name="TextBox 17459"/>
-          <p:cNvSpPr txBox="1"/>
-          <p:nvPr/>
-        </p:nvSpPr>
-        <p:spPr>
-          <a:xfrm>
-            <a:off x="8001000" y="3359505"/>
-            <a:ext cx="3422599" cy="352958"/>
-          </a:xfrm>
-          <a:prstGeom prst="rect">
-            <a:avLst/>
-          </a:prstGeom>
-          <a:noFill/>
-        </p:spPr>
-        <p:txBody>
-          <a:bodyPr wrap="square" lIns="0" rIns="0" tIns="0" bIns="0" anchor="ctr">
-            <a:noAutofit/>
-          </a:bodyPr>
-          <a:lstStyle/>
-          <a:p>
-            <a:pPr algn="l" marL="0" indent="0">
-              <a:spcBef>
-                <a:spcPts val="0"/>
-              </a:spcBef>
-              <a:spcAft>
-                <a:spcPts val="0"/>
-              </a:spcAft>
-              <a:buNone/>
-            </a:pPr>
-            <a:r>
-              <a:rPr sz="940" b="0" i="0" lang="en-US">
-                <a:solidFill>
-                  <a:srgbClr val="1E2638"/>
-                </a:solidFill>
-                <a:latin typeface="Calibri"/>
-              </a:rPr>
-              <a:t>PyTorch / ONNX Runtime — quantized INT8 heatmap candidate localizer for low-contrast fog</a:t>
-            </a:r>
-          </a:p>
-        </p:txBody>
-      </p:sp>
-      <p:cxnSp>
-        <p:nvCxnSpPr>
-          <p:cNvPr id="17461" name="Connector 17460"/>
-          <p:cNvCxnSpPr/>
-          <p:nvPr/>
-        </p:nvCxnSpPr>
-        <p:spPr>
-          <a:xfrm>
-            <a:off x="6373368" y="3721608"/>
-            <a:ext cx="5068519" cy="0"/>
-          </a:xfrm>
-          <a:prstGeom prst="line">
-            <a:avLst/>
-          </a:prstGeom>
-          <a:ln w="9525">
-            <a:solidFill>
-              <a:srgbClr val="D9E2EE"/>
-            </a:solidFill>
-          </a:ln>
-        </p:spPr>
-      </p:cxnSp>
-      <p:sp>
-        <p:nvSpPr>
-          <p:cNvPr id="17462" name="TextBox 17461"/>
-          <p:cNvSpPr txBox="1"/>
-          <p:nvPr/>
-        </p:nvSpPr>
-        <p:spPr>
-          <a:xfrm>
-            <a:off x="6373368" y="3739896"/>
-            <a:ext cx="1600200" cy="352958"/>
-          </a:xfrm>
-          <a:prstGeom prst="rect">
-            <a:avLst/>
-          </a:prstGeom>
-          <a:noFill/>
-        </p:spPr>
-        <p:txBody>
-          <a:bodyPr wrap="square" lIns="0" rIns="0" tIns="0" bIns="0" anchor="ctr">
-            <a:noAutofit/>
-          </a:bodyPr>
-          <a:lstStyle/>
-          <a:p>
-            <a:pPr algn="l" marL="0" indent="0">
-              <a:spcBef>
-                <a:spcPts val="0"/>
-              </a:spcBef>
-              <a:spcAft>
-                <a:spcPts val="0"/>
-              </a:spcAft>
-              <a:buNone/>
-            </a:pPr>
-            <a:r>
-              <a:rPr sz="980" b="1" i="0" lang="en-US">
-                <a:solidFill>
-                  <a:srgbClr val="14345C"/>
-                </a:solidFill>
-                <a:latin typeface="Calibri"/>
-              </a:rPr>
-              <a:t>Sub-Pixel Centroiding</a:t>
-            </a:r>
-          </a:p>
-        </p:txBody>
-      </p:sp>
-      <p:sp>
-        <p:nvSpPr>
-          <p:cNvPr id="17463" name="TextBox 17462"/>
-          <p:cNvSpPr txBox="1"/>
-          <p:nvPr/>
-        </p:nvSpPr>
-        <p:spPr>
-          <a:xfrm>
-            <a:off x="8001000" y="3739896"/>
-            <a:ext cx="3422599" cy="352958"/>
-          </a:xfrm>
-          <a:prstGeom prst="rect">
-            <a:avLst/>
-          </a:prstGeom>
-          <a:noFill/>
-        </p:spPr>
-        <p:txBody>
-          <a:bodyPr wrap="square" lIns="0" rIns="0" tIns="0" bIns="0" anchor="ctr">
-            <a:noAutofit/>
-          </a:bodyPr>
-          <a:lstStyle/>
-          <a:p>
-            <a:pPr algn="l" marL="0" indent="0">
-              <a:spcBef>
-                <a:spcPts val="0"/>
-              </a:spcBef>
-              <a:spcAft>
-                <a:spcPts val="0"/>
-              </a:spcAft>
-              <a:buNone/>
-            </a:pPr>
-            <a:r>
-              <a:rPr sz="940" b="0" i="0" lang="en-US">
-                <a:solidFill>
-                  <a:srgbClr val="1E2638"/>
-                </a:solidFill>
-                <a:latin typeface="Calibri"/>
-              </a:rPr>
-              <a:t>Continuous 2D Gaussian gray-diffusion surface fitting (&lt; 0.2 px sub-pixel resolution)</a:t>
-            </a:r>
-          </a:p>
-        </p:txBody>
-      </p:sp>
-      <p:cxnSp>
-        <p:nvCxnSpPr>
-          <p:cNvPr id="17464" name="Connector 17463"/>
-          <p:cNvCxnSpPr/>
-          <p:nvPr/>
-        </p:nvCxnSpPr>
-        <p:spPr>
-          <a:xfrm>
-            <a:off x="6373368" y="4101998"/>
-            <a:ext cx="5068519" cy="0"/>
-          </a:xfrm>
-          <a:prstGeom prst="line">
-            <a:avLst/>
-          </a:prstGeom>
-          <a:ln w="9525">
-            <a:solidFill>
-              <a:srgbClr val="D9E2EE"/>
-            </a:solidFill>
-          </a:ln>
-        </p:spPr>
-      </p:cxnSp>
-      <p:sp>
-        <p:nvSpPr>
-          <p:cNvPr id="17465" name="TextBox 17464"/>
-          <p:cNvSpPr txBox="1"/>
-          <p:nvPr/>
-        </p:nvSpPr>
-        <p:spPr>
-          <a:xfrm>
-            <a:off x="6373368" y="4120286"/>
-            <a:ext cx="1600200" cy="352958"/>
-          </a:xfrm>
-          <a:prstGeom prst="rect">
-            <a:avLst/>
-          </a:prstGeom>
-          <a:noFill/>
-        </p:spPr>
-        <p:txBody>
-          <a:bodyPr wrap="square" lIns="0" rIns="0" tIns="0" bIns="0" anchor="ctr">
-            <a:noAutofit/>
-          </a:bodyPr>
-          <a:lstStyle/>
-          <a:p>
-            <a:pPr algn="l" marL="0" indent="0">
-              <a:spcBef>
-                <a:spcPts val="0"/>
-              </a:spcBef>
-              <a:spcAft>
-                <a:spcPts val="0"/>
-              </a:spcAft>
-              <a:buNone/>
-            </a:pPr>
-            <a:r>
-              <a:rPr sz="980" b="1" i="0" lang="en-US">
-                <a:solidFill>
-                  <a:srgbClr val="14345C"/>
-                </a:solidFill>
-                <a:latin typeface="Calibri"/>
-              </a:rPr>
-              <a:t>Kinematic Estimation</a:t>
-            </a:r>
-          </a:p>
-        </p:txBody>
-      </p:sp>
-      <p:sp>
-        <p:nvSpPr>
-          <p:cNvPr id="17466" name="TextBox 17465"/>
-          <p:cNvSpPr txBox="1"/>
-          <p:nvPr/>
-        </p:nvSpPr>
-        <p:spPr>
-          <a:xfrm>
-            <a:off x="8001000" y="4120286"/>
-            <a:ext cx="3422599" cy="352958"/>
-          </a:xfrm>
-          <a:prstGeom prst="rect">
-            <a:avLst/>
-          </a:prstGeom>
-          <a:noFill/>
-        </p:spPr>
-        <p:txBody>
-          <a:bodyPr wrap="square" lIns="0" rIns="0" tIns="0" bIns="0" anchor="ctr">
-            <a:noAutofit/>
-          </a:bodyPr>
-          <a:lstStyle/>
-          <a:p>
-            <a:pPr algn="l" marL="0" indent="0">
-              <a:spcBef>
-                <a:spcPts val="0"/>
-              </a:spcBef>
-              <a:spcAft>
-                <a:spcPts val="0"/>
-              </a:spcAft>
-              <a:buNone/>
-            </a:pPr>
-            <a:r>
-              <a:rPr sz="940" b="0" i="0" lang="en-US">
-                <a:solidFill>
-                  <a:srgbClr val="1E2638"/>
-                </a:solidFill>
-                <a:latin typeface="Calibri"/>
-              </a:rPr>
-              <a:t>Interacting Multiple Model (IMM) filter combining Constant Velocity &amp; Coordinated Turn</a:t>
-            </a:r>
-          </a:p>
-        </p:txBody>
-      </p:sp>
-      <p:cxnSp>
-        <p:nvCxnSpPr>
-          <p:cNvPr id="17467" name="Connector 17466"/>
-          <p:cNvCxnSpPr/>
-          <p:nvPr/>
-        </p:nvCxnSpPr>
-        <p:spPr>
-          <a:xfrm>
-            <a:off x="6373368" y="4482388"/>
-            <a:ext cx="5068519" cy="0"/>
-          </a:xfrm>
-          <a:prstGeom prst="line">
-            <a:avLst/>
-          </a:prstGeom>
-          <a:ln w="9525">
-            <a:solidFill>
-              <a:srgbClr val="D9E2EE"/>
-            </a:solidFill>
-          </a:ln>
-        </p:spPr>
-      </p:cxnSp>
-      <p:sp>
-        <p:nvSpPr>
-          <p:cNvPr id="17468" name="TextBox 17467"/>
-          <p:cNvSpPr txBox="1"/>
-          <p:nvPr/>
-        </p:nvSpPr>
-        <p:spPr>
-          <a:xfrm>
-            <a:off x="6373368" y="4500676"/>
-            <a:ext cx="1600200" cy="352958"/>
-          </a:xfrm>
-          <a:prstGeom prst="rect">
-            <a:avLst/>
-          </a:prstGeom>
-          <a:noFill/>
-        </p:spPr>
-        <p:txBody>
-          <a:bodyPr wrap="square" lIns="0" rIns="0" tIns="0" bIns="0" anchor="ctr">
-            <a:noAutofit/>
-          </a:bodyPr>
-          <a:lstStyle/>
-          <a:p>
-            <a:pPr algn="l" marL="0" indent="0">
-              <a:spcBef>
-                <a:spcPts val="0"/>
-              </a:spcBef>
-              <a:spcAft>
-                <a:spcPts val="0"/>
-              </a:spcAft>
-              <a:buNone/>
-            </a:pPr>
-            <a:r>
-              <a:rPr sz="980" b="1" i="0" lang="en-US">
-                <a:solidFill>
-                  <a:srgbClr val="14345C"/>
-                </a:solidFill>
-                <a:latin typeface="Calibri"/>
-              </a:rPr>
-              <a:t>Servo Control Loop</a:t>
-            </a:r>
-          </a:p>
-        </p:txBody>
-      </p:sp>
-      <p:sp>
-        <p:nvSpPr>
-          <p:cNvPr id="17469" name="TextBox 17468"/>
-          <p:cNvSpPr txBox="1"/>
-          <p:nvPr/>
-        </p:nvSpPr>
-        <p:spPr>
-          <a:xfrm>
-            <a:off x="8001000" y="4500676"/>
-            <a:ext cx="3422599" cy="352958"/>
-          </a:xfrm>
-          <a:prstGeom prst="rect">
-            <a:avLst/>
-          </a:prstGeom>
-          <a:noFill/>
-        </p:spPr>
-        <p:txBody>
-          <a:bodyPr wrap="square" lIns="0" rIns="0" tIns="0" bIns="0" anchor="ctr">
-            <a:noAutofit/>
-          </a:bodyPr>
-          <a:lstStyle/>
-          <a:p>
-            <a:pPr algn="l" marL="0" indent="0">
-              <a:spcBef>
-                <a:spcPts val="0"/>
-              </a:spcBef>
-              <a:spcAft>
-                <a:spcPts val="0"/>
-              </a:spcAft>
-              <a:buNone/>
-            </a:pPr>
-            <a:r>
-              <a:rPr sz="940" b="0" i="0" lang="en-US">
-                <a:solidFill>
-                  <a:srgbClr val="1E2638"/>
-                </a:solidFill>
-                <a:latin typeface="Calibri"/>
-              </a:rPr>
-              <a:t>Feedforward predictive anti-windup PID (strict 5-10°/s physical slew rate clamping)</a:t>
-            </a:r>
-          </a:p>
-        </p:txBody>
-      </p:sp>
-      <p:cxnSp>
-        <p:nvCxnSpPr>
-          <p:cNvPr id="17470" name="Connector 17469"/>
-          <p:cNvCxnSpPr/>
-          <p:nvPr/>
-        </p:nvCxnSpPr>
-        <p:spPr>
-          <a:xfrm>
-            <a:off x="6373368" y="4862779"/>
-            <a:ext cx="5068519" cy="0"/>
-          </a:xfrm>
-          <a:prstGeom prst="line">
-            <a:avLst/>
-          </a:prstGeom>
-          <a:ln w="9525">
-            <a:solidFill>
-              <a:srgbClr val="D9E2EE"/>
-            </a:solidFill>
-          </a:ln>
-        </p:spPr>
-      </p:cxnSp>
-      <p:sp>
-        <p:nvSpPr>
-          <p:cNvPr id="17471" name="TextBox 17470"/>
-          <p:cNvSpPr txBox="1"/>
-          <p:nvPr/>
-        </p:nvSpPr>
-        <p:spPr>
-          <a:xfrm>
-            <a:off x="6373368" y="4881067"/>
-            <a:ext cx="1600200" cy="352958"/>
-          </a:xfrm>
-          <a:prstGeom prst="rect">
-            <a:avLst/>
-          </a:prstGeom>
-          <a:noFill/>
-        </p:spPr>
-        <p:txBody>
-          <a:bodyPr wrap="square" lIns="0" rIns="0" tIns="0" bIns="0" anchor="ctr">
-            <a:noAutofit/>
-          </a:bodyPr>
-          <a:lstStyle/>
-          <a:p>
-            <a:pPr algn="l" marL="0" indent="0">
-              <a:spcBef>
-                <a:spcPts val="0"/>
-              </a:spcBef>
-              <a:spcAft>
-                <a:spcPts val="0"/>
-              </a:spcAft>
-              <a:buNone/>
-            </a:pPr>
-            <a:r>
-              <a:rPr sz="980" b="1" i="0" lang="en-US">
-                <a:solidFill>
-                  <a:srgbClr val="14345C"/>
-                </a:solidFill>
-                <a:latin typeface="Calibri"/>
-              </a:rPr>
-              <a:t>Tactical Cockpit GUI</a:t>
-            </a:r>
-          </a:p>
-        </p:txBody>
-      </p:sp>
-      <p:sp>
-        <p:nvSpPr>
-          <p:cNvPr id="17472" name="TextBox 17471"/>
-          <p:cNvSpPr txBox="1"/>
-          <p:nvPr/>
-        </p:nvSpPr>
-        <p:spPr>
-          <a:xfrm>
-            <a:off x="8001000" y="4881067"/>
-            <a:ext cx="3422599" cy="352958"/>
-          </a:xfrm>
-          <a:prstGeom prst="rect">
-            <a:avLst/>
-          </a:prstGeom>
-          <a:noFill/>
-        </p:spPr>
-        <p:txBody>
-          <a:bodyPr wrap="square" lIns="0" rIns="0" tIns="0" bIns="0" anchor="ctr">
-            <a:noAutofit/>
-          </a:bodyPr>
-          <a:lstStyle/>
-          <a:p>
-            <a:pPr algn="l" marL="0" indent="0">
-              <a:spcBef>
-                <a:spcPts val="0"/>
-              </a:spcBef>
-              <a:spcAft>
-                <a:spcPts val="0"/>
-              </a:spcAft>
-              <a:buNone/>
-            </a:pPr>
-            <a:r>
-              <a:t>OpenCV Tactical Cockpit &amp; Web Mission Control (Chart.js / HTTP 8080) with operator PTZ override</a:t>
-            </a:r>
-          </a:p>
-        </p:txBody>
-      </p:sp>
-      <p:cxnSp>
-        <p:nvCxnSpPr>
-          <p:cNvPr id="17473" name="Connector 17472"/>
-          <p:cNvCxnSpPr/>
-          <p:nvPr/>
-        </p:nvCxnSpPr>
-        <p:spPr>
-          <a:xfrm>
-            <a:off x="6373368" y="5243169"/>
-            <a:ext cx="5068519" cy="0"/>
-          </a:xfrm>
-          <a:prstGeom prst="line">
-            <a:avLst/>
-          </a:prstGeom>
-          <a:ln w="9525">
-            <a:solidFill>
-              <a:srgbClr val="D9E2EE"/>
-            </a:solidFill>
-          </a:ln>
-        </p:spPr>
-      </p:cxnSp>
-      <p:sp>
-        <p:nvSpPr>
-          <p:cNvPr id="17474" name="TextBox 17473"/>
-          <p:cNvSpPr txBox="1"/>
-          <p:nvPr/>
-        </p:nvSpPr>
-        <p:spPr>
-          <a:xfrm>
-            <a:off x="6373368" y="5261457"/>
-            <a:ext cx="1600200" cy="352958"/>
-          </a:xfrm>
-          <a:prstGeom prst="rect">
-            <a:avLst/>
-          </a:prstGeom>
-          <a:noFill/>
-        </p:spPr>
-        <p:txBody>
-          <a:bodyPr wrap="square" lIns="0" rIns="0" tIns="0" bIns="0" anchor="ctr">
-            <a:noAutofit/>
-          </a:bodyPr>
-          <a:lstStyle/>
-          <a:p>
-            <a:pPr algn="l" marL="0" indent="0">
-              <a:spcBef>
-                <a:spcPts val="0"/>
-              </a:spcBef>
-              <a:spcAft>
-                <a:spcPts val="0"/>
-              </a:spcAft>
-              <a:buNone/>
-            </a:pPr>
-            <a:r>
-              <a:rPr sz="980" b="1" i="0" lang="en-US">
-                <a:solidFill>
-                  <a:srgbClr val="14345C"/>
-                </a:solidFill>
-                <a:latin typeface="Calibri"/>
-              </a:rPr>
-              <a:t>Compliance Suite</a:t>
-            </a:r>
-          </a:p>
-        </p:txBody>
-      </p:sp>
-      <p:sp>
-        <p:nvSpPr>
-          <p:cNvPr id="17475" name="TextBox 17474"/>
-          <p:cNvSpPr txBox="1"/>
-          <p:nvPr/>
-        </p:nvSpPr>
-        <p:spPr>
-          <a:xfrm>
-            <a:off x="8001000" y="5261457"/>
-            <a:ext cx="3422599" cy="352958"/>
-          </a:xfrm>
-          <a:prstGeom prst="rect">
-            <a:avLst/>
-          </a:prstGeom>
-          <a:noFill/>
-        </p:spPr>
-        <p:txBody>
-          <a:bodyPr wrap="square" lIns="0" rIns="0" tIns="0" bIns="0" anchor="ctr">
-            <a:noAutofit/>
-          </a:bodyPr>
-          <a:lstStyle/>
-          <a:p>
-            <a:pPr algn="l" marL="0" indent="0">
-              <a:spcBef>
-                <a:spcPts val="0"/>
-              </a:spcBef>
-              <a:spcAft>
-                <a:spcPts val="0"/>
-              </a:spcAft>
-              <a:buNone/>
-            </a:pPr>
-            <a:r>
-              <a:rPr sz="940" b="0" i="0" lang="en-US">
-                <a:solidFill>
-                  <a:srgbClr val="1E2638"/>
-                </a:solidFill>
-                <a:latin typeface="Calibri"/>
-              </a:rPr>
-              <a:t>Automated CSV/PDF Benchmark-2 audit engine logging RMSE, latency, and lock retention</a:t>
-            </a:r>
-          </a:p>
-        </p:txBody>
-      </p:sp>
-      <p:cxnSp>
-        <p:nvCxnSpPr>
-          <p:cNvPr id="17476" name="Connector 17475"/>
-          <p:cNvCxnSpPr/>
-          <p:nvPr/>
-        </p:nvCxnSpPr>
-        <p:spPr>
-          <a:xfrm>
-            <a:off x="6373368" y="5623560"/>
-            <a:ext cx="5068519" cy="0"/>
-          </a:xfrm>
-          <a:prstGeom prst="line">
-            <a:avLst/>
-          </a:prstGeom>
-          <a:ln w="9525">
-            <a:solidFill>
-              <a:srgbClr val="D9E2EE"/>
-            </a:solidFill>
-          </a:ln>
-        </p:spPr>
-      </p:cxnSp>
-      <p:sp>
-        <p:nvSpPr>
-          <p:cNvPr id="17477" name="TextBox 17476"/>
-          <p:cNvSpPr txBox="1"/>
-          <p:nvPr/>
-        </p:nvSpPr>
-        <p:spPr>
-          <a:xfrm>
-            <a:off x="6373368" y="5641848"/>
-            <a:ext cx="1600200" cy="352958"/>
-          </a:xfrm>
-          <a:prstGeom prst="rect">
-            <a:avLst/>
-          </a:prstGeom>
-          <a:noFill/>
-        </p:spPr>
-        <p:txBody>
-          <a:bodyPr wrap="square" lIns="0" rIns="0" tIns="0" bIns="0" anchor="ctr">
-            <a:noAutofit/>
-          </a:bodyPr>
-          <a:lstStyle/>
-          <a:p>
-            <a:pPr algn="l" marL="0" indent="0">
-              <a:spcBef>
-                <a:spcPts val="0"/>
-              </a:spcBef>
-              <a:spcAft>
-                <a:spcPts val="0"/>
-              </a:spcAft>
-              <a:buNone/>
-            </a:pPr>
-            <a:r>
-              <a:rPr sz="980" b="1" i="0" lang="en-US">
-                <a:solidFill>
-                  <a:srgbClr val="14345C"/>
-                </a:solidFill>
-                <a:latin typeface="Calibri"/>
-              </a:rPr>
-              <a:t>Cross-Platform CI</a:t>
-            </a:r>
-          </a:p>
-        </p:txBody>
-      </p:sp>
-      <p:sp>
-        <p:nvSpPr>
-          <p:cNvPr id="17478" name="TextBox 17477"/>
-          <p:cNvSpPr txBox="1"/>
-          <p:nvPr/>
-        </p:nvSpPr>
-        <p:spPr>
-          <a:xfrm>
-            <a:off x="8001000" y="5641848"/>
-            <a:ext cx="3422599" cy="352958"/>
-          </a:xfrm>
-          <a:prstGeom prst="rect">
-            <a:avLst/>
-          </a:prstGeom>
-          <a:noFill/>
-        </p:spPr>
-        <p:txBody>
-          <a:bodyPr wrap="square" lIns="0" rIns="0" tIns="0" bIns="0" anchor="ctr">
-            <a:noAutofit/>
-          </a:bodyPr>
-          <a:lstStyle/>
-          <a:p>
-            <a:pPr algn="l" marL="0" indent="0">
-              <a:spcBef>
-                <a:spcPts val="0"/>
-              </a:spcBef>
-              <a:spcAft>
-                <a:spcPts val="0"/>
-              </a:spcAft>
-              <a:buNone/>
-            </a:pPr>
-            <a:r>
-              <a:rPr sz="940" b="0" i="0" lang="en-US">
-                <a:solidFill>
-                  <a:srgbClr val="1E2638"/>
-                </a:solidFill>
-                <a:latin typeface="Calibri"/>
-              </a:rPr>
-              <a:t>GitHub Actions CI pipeline compiling standalone Windows .exe and macOS app binaries</a:t>
-            </a:r>
-          </a:p>
-        </p:txBody>
-      </p:sp>
     </p:spTree>
   </p:cSld>
   <p:clrMapOvr>
@@ -15192,79 +14399,9 @@
           </a:bodyPr>
           <a:lstStyle/>
           <a:p>
-            <a:pPr algn="l" marL="0" indent="0">
-              <a:spcBef>
-                <a:spcPts val="0"/>
-              </a:spcBef>
-              <a:spcAft>
-                <a:spcPts val="0"/>
-              </a:spcAft>
-              <a:buNone/>
-            </a:pPr>
-            <a:r>
-              <a:rPr sz="1000" b="1" i="0" lang="en-US" spc="50">
-                <a:solidFill>
-                  <a:srgbClr val="B35A00"/>
-                </a:solidFill>
-                <a:latin typeface="Calibri"/>
-              </a:rPr>
-              <a:t>SPACE AVIONICS ROADMAP</a:t>
-            </a:r>
-          </a:p>
-        </p:txBody>
-      </p:sp>
-      <p:sp>
-        <p:nvSpPr>
-          <p:cNvPr id="17463" name="TextBox 17462"/>
-          <p:cNvSpPr txBox="1"/>
-          <p:nvPr/>
-        </p:nvSpPr>
-        <p:spPr>
-          <a:xfrm>
-            <a:off x="4434840" y="4965192"/>
-            <a:ext cx="3118104" cy="822960"/>
-          </a:xfrm>
-          <a:prstGeom prst="rect">
-            <a:avLst/>
-          </a:prstGeom>
-          <a:noFill/>
-        </p:spPr>
-        <p:txBody>
-          <a:bodyPr wrap="square" lIns="0" rIns="0" tIns="0" bIns="0" anchor="t">
-            <a:noAutofit/>
-          </a:bodyPr>
-          <a:lstStyle/>
-          <a:p>
-            <a:pPr algn="l" marL="137160" indent="-137160">
-              <a:spcBef>
-                <a:spcPts val="0"/>
-              </a:spcBef>
-              <a:spcAft>
-                <a:spcPts val="200"/>
-              </a:spcAft>
-              <a:buClr>
-                <a:srgbClr val="D9700F"/>
-              </a:buClr>
-              <a:buFont typeface="Arial"/>
-              <a:buChar char="•"/>
-            </a:pPr>
-            <a:r>
-              <a:rPr sz="919" b="1" i="0" lang="en-US">
-                <a:solidFill>
-                  <a:srgbClr val="14345C"/>
-                </a:solidFill>
-                <a:latin typeface="Calibri"/>
-              </a:rPr>
-              <a:t>Algorithmic Flight Readiness: </a:t>
-            </a:r>
-            <a:r>
-              <a:rPr sz="919" b="0" i="0" lang="en-US">
-                <a:solidFill>
-                  <a:srgbClr val="1E2638"/>
-                </a:solidFill>
-                <a:latin typeface="Calibri"/>
-              </a:rPr>
-              <a:t>Lightweight model architecture synthesizable into space-grade Xilinx Zynq UltraScale+ FPGA or Jetson Orin Nano flight computers (&lt; 15W).</a:t>
+            <a:r>
+              <a:rPr sz="900" b="1"/>
+              <a:t>OPTICAL CHANNEL VALIDATION</a:t>
             </a:r>
           </a:p>
         </p:txBody>
@@ -16170,7 +15307,8 @@
               <a:buNone/>
             </a:pPr>
             <a:r>
-              <a:t>Distributed Network &amp; Multi-Node IPC Latency</a:t>
+              <a:rPr sz="900"/>
+              <a:t>Multi-Terminal Network Latency</a:t>
             </a:r>
           </a:p>
         </p:txBody>
@@ -16210,11 +15348,36 @@
               <a:buNone/>
             </a:pPr>
             <a:r>
-              <a:t>→ Non-blocking UDP transport with 8KB MTU fragmentation: decouples 30 Hz edge vision from 60 Hz web cockpit with zero network lag.</a:t>
-            </a:r>
-          </a:p>
-        </p:txBody>
-      </p:sp>
+              <a:rPr sz="800"/>
+              <a:t>→ Non-blocking UDP with 8KB MTU fragmentation decouples 30 Hz edge vision from 60 Hz web cockpit with zero packet lag.</a:t>
+            </a:r>
+          </a:p>
+        </p:txBody>
+      </p:sp>
+      <p:pic>
+        <p:nvPicPr>
+          <p:cNvPr id="17487" name="Picture 17486" descr="04_optical_disturbances_comparison.png"/>
+          <p:cNvPicPr>
+            <a:picLocks noChangeAspect="1"/>
+          </p:cNvPicPr>
+          <p:nvPr/>
+        </p:nvPicPr>
+        <p:blipFill>
+          <a:blip r:embed="rId10"/>
+          <a:stretch>
+            <a:fillRect/>
+          </a:stretch>
+        </p:blipFill>
+        <p:spPr>
+          <a:xfrm>
+            <a:off x="4434840" y="4160520"/>
+            <a:ext cx="3246120" cy="2011680"/>
+          </a:xfrm>
+          <a:prstGeom prst="rect">
+            <a:avLst/>
+          </a:prstGeom>
+        </p:spPr>
+      </p:pic>
     </p:spTree>
     <p:extLst>
       <p:ext uri="{BB962C8B-B14F-4D97-AF65-F5344CB8AC3E}">
@@ -19402,89 +18565,6 @@
       </p:sp>
       <p:sp>
         <p:nvSpPr>
-          <p:cNvPr id="6" name="Slide Number Placeholder 5"/>
-          <p:cNvSpPr>
-            <a:spLocks noGrp="1"/>
-          </p:cNvSpPr>
-          <p:nvPr>
-            <p:ph type="sldNum" sz="quarter" idx="12"/>
-          </p:nvPr>
-        </p:nvSpPr>
-        <p:spPr/>
-        <p:txBody>
-          <a:bodyPr/>
-          <a:lstStyle/>
-          <a:p>
-            <a:pPr marL="0" marR="0" lvl="0" indent="0" algn="r" defTabSz="457200" rtl="0" eaLnBrk="1" fontAlgn="base" latinLnBrk="0" hangingPunct="1">
-              <a:lnSpc>
-                <a:spcPct val="100000"/>
-              </a:lnSpc>
-              <a:spcBef>
-                <a:spcPct val="0"/>
-              </a:spcBef>
-              <a:spcAft>
-                <a:spcPct val="0"/>
-              </a:spcAft>
-              <a:buClrTx/>
-              <a:buSzTx/>
-              <a:buFontTx/>
-              <a:buNone/>
-              <a:tabLst/>
-              <a:defRPr/>
-            </a:pPr>
-            <a:fld id="{677C3CE7-23F7-4828-823C-E0205DF2CF97}" type="slidenum">
-              <a:rPr kumimoji="0" lang="en-US" sz="1200" b="1" i="0" u="none" strike="noStrike" kern="1200" cap="none" spc="0" normalizeH="0" baseline="0" noProof="0">
-                <a:ln>
-                  <a:noFill/>
-                </a:ln>
-                <a:solidFill>
-                  <a:prstClr val="white"/>
-                </a:solidFill>
-                <a:effectLst/>
-                <a:uLnTx/>
-                <a:uFillTx/>
-                <a:latin typeface="TradeGothic" pitchFamily="1" charset="0"/>
-                <a:ea typeface="ＭＳ Ｐゴシック" pitchFamily="1" charset="-128"/>
-                <a:cs typeface="+mn-cs"/>
-              </a:rPr>
-              <a:pPr marL="0" marR="0" lvl="0" indent="0" algn="r" defTabSz="457200" rtl="0" eaLnBrk="1" fontAlgn="base" latinLnBrk="0" hangingPunct="1">
-                <a:lnSpc>
-                  <a:spcPct val="100000"/>
-                </a:lnSpc>
-                <a:spcBef>
-                  <a:spcPct val="0"/>
-                </a:spcBef>
-                <a:spcAft>
-                  <a:spcPct val="0"/>
-                </a:spcAft>
-                <a:buClrTx/>
-                <a:buSzTx/>
-                <a:buFontTx/>
-                <a:buNone/>
-                <a:tabLst/>
-                <a:defRPr/>
-              </a:pPr>
-              <a:t>6</a:t>
-            </a:fld>
-            <a:endParaRPr kumimoji="0" lang="en-US" sz="1200" b="1" i="0" u="none" strike="noStrike" kern="1200" cap="none" spc="0" normalizeH="0" baseline="0" noProof="0" dirty="0">
-              <a:ln>
-                <a:noFill/>
-              </a:ln>
-              <a:solidFill>
-                <a:prstClr val="white"/>
-              </a:solidFill>
-              <a:effectLst/>
-              <a:uLnTx/>
-              <a:uFillTx/>
-              <a:latin typeface="TradeGothic" pitchFamily="1" charset="0"/>
-              <a:ea typeface="ＭＳ Ｐゴシック" pitchFamily="1" charset="-128"/>
-              <a:cs typeface="+mn-cs"/>
-            </a:endParaRPr>
-          </a:p>
-        </p:txBody>
-      </p:sp>
-      <p:sp>
-        <p:nvSpPr>
           <p:cNvPr id="7" name="Footer Placeholder 6"/>
           <p:cNvSpPr>
             <a:spLocks noGrp="1"/>
@@ -21328,889 +20408,101 @@
                 <a:spcPts val="0"/>
               </a:spcAft>
               <a:buNone/>
-            </a:pPr>
-            <a:r>
-              <a:rPr sz="810" b="0" i="0" lang="en-US">
-                <a:solidFill>
-                  <a:srgbClr val="1E2638"/>
-                </a:solidFill>
-                <a:latin typeface="Consolas"/>
-              </a:rPr>
-              <a:t>1. docs/system_architecture_plan.md</a:t>
-            </a:r>
-          </a:p>
-          <a:p>
-            <a:pPr algn="l" marL="0" indent="0">
-              <a:spcBef>
-                <a:spcPts val="0"/>
-              </a:spcBef>
-              <a:spcAft>
-                <a:spcPts val="400"/>
-              </a:spcAft>
-              <a:buNone/>
-            </a:pPr>
-            <a:r>
-              <a:rPr sz="760" b="0" i="1" lang="en-US">
-                <a:solidFill>
-                  <a:srgbClr val="566074"/>
-                </a:solidFill>
-                <a:latin typeface="Calibri"/>
-              </a:rPr>
-              <a:t>(Complete Code Blueprint)</a:t>
-            </a:r>
-          </a:p>
-          <a:p>
-            <a:pPr algn="l" marL="0" indent="0">
-              <a:spcBef>
-                <a:spcPts val="0"/>
-              </a:spcBef>
-              <a:spcAft>
-                <a:spcPts val="0"/>
-              </a:spcAft>
-              <a:buNone/>
-            </a:pPr>
-            <a:r>
-              <a:rPr sz="810" b="0" i="0" lang="en-US">
-                <a:solidFill>
-                  <a:srgbClr val="1E2638"/>
-                </a:solidFill>
-                <a:latin typeface="Consolas"/>
-              </a:rPr>
-              <a:t>2. academic_research/literature_review_and_citations.md</a:t>
-            </a:r>
-          </a:p>
-          <a:p>
-            <a:pPr algn="l" marL="0" indent="0">
-              <a:spcBef>
-                <a:spcPts val="0"/>
-              </a:spcBef>
-              <a:spcAft>
-                <a:spcPts val="200"/>
-              </a:spcAft>
-              <a:buNone/>
-            </a:pPr>
-            <a:r>
-              <a:rPr sz="200" b="0" i="0" lang="en-US">
-                <a:solidFill>
-                  <a:srgbClr val="1E2638"/>
-                </a:solidFill>
-                <a:latin typeface="Consolas"/>
-              </a:rPr>
-              <a:t/>
-            </a:r>
-          </a:p>
-          <a:p>
-            <a:pPr algn="l" marL="0" indent="0">
-              <a:spcBef>
-                <a:spcPts val="0"/>
-              </a:spcBef>
-              <a:spcAft>
-                <a:spcPts val="0"/>
-              </a:spcAft>
-              <a:buNone/>
-            </a:pPr>
-            <a:r>
-              <a:rPr sz="810" b="0" i="0" lang="en-US">
-                <a:solidFill>
-                  <a:srgbClr val="1E2638"/>
-                </a:solidFill>
-                <a:latin typeface="Consolas"/>
-              </a:rPr>
-              <a:t>3. academic_research/papers/</a:t>
-            </a:r>
-          </a:p>
-          <a:p>
-            <a:pPr algn="l" marL="0" indent="0">
-              <a:spcBef>
-                <a:spcPts val="0"/>
-              </a:spcBef>
-              <a:spcAft>
-                <a:spcPts val="400"/>
-              </a:spcAft>
-              <a:buNone/>
-            </a:pPr>
-            <a:r>
-              <a:rPr sz="760" b="0" i="1" lang="en-US">
-                <a:solidFill>
-                  <a:srgbClr val="566074"/>
-                </a:solidFill>
-                <a:latin typeface="Calibri"/>
-              </a:rPr>
-              <a:t>(Downloaded CVPR &amp; ECCV PDFs)</a:t>
-            </a:r>
-          </a:p>
-          <a:p>
-            <a:pPr algn="l" marL="0" indent="0">
-              <a:spcBef>
-                <a:spcPts val="0"/>
-              </a:spcBef>
-              <a:spcAft>
-                <a:spcPts val="0"/>
-              </a:spcAft>
-              <a:buNone/>
-            </a:pPr>
-            <a:r>
-              <a:rPr sz="810" b="0" i="0" lang="en-US">
-                <a:solidFill>
-                  <a:srgbClr val="1E2638"/>
-                </a:solidFill>
-                <a:latin typeface="Consolas"/>
-              </a:rPr>
-              <a:t>4. presentation/generate_presentation.py</a:t>
-            </a:r>
-          </a:p>
-          <a:p>
-            <a:pPr algn="l" marL="0" indent="0">
-              <a:spcBef>
-                <a:spcPts val="0"/>
-              </a:spcBef>
-              <a:spcAft>
-                <a:spcPts val="400"/>
-              </a:spcAft>
-              <a:buNone/>
-            </a:pPr>
-            <a:r>
-              <a:rPr sz="760" b="0" i="1" lang="en-US">
-                <a:solidFill>
-                  <a:srgbClr val="566074"/>
-                </a:solidFill>
-                <a:latin typeface="Calibri"/>
-              </a:rPr>
-              <a:t>(Automated SIH Deck)</a:t>
-            </a:r>
-          </a:p>
-        </p:txBody>
-      </p:sp>
-      <p:cxnSp>
-        <p:nvCxnSpPr>
-          <p:cNvPr id="17449" name="Connector 17448"/>
-          <p:cNvCxnSpPr/>
-          <p:nvPr/>
-        </p:nvCxnSpPr>
-        <p:spPr>
-          <a:xfrm>
-            <a:off x="7836408" y="3941063"/>
-            <a:ext cx="3605479" cy="0"/>
-          </a:xfrm>
-          <a:prstGeom prst="line">
-            <a:avLst/>
-          </a:prstGeom>
-          <a:ln w="12700">
-            <a:solidFill>
-              <a:srgbClr val="D9E2EE"/>
-            </a:solidFill>
-          </a:ln>
-        </p:spPr>
-      </p:cxnSp>
-      <p:sp>
-        <p:nvSpPr>
-          <p:cNvPr id="17450" name="TextBox 17449"/>
+              <a:defRPr sz="800">
+                <a:solidFill>
+                  <a:srgbClr val="3C3C3C"/>
+                </a:solidFill>
+              </a:defRPr>
+            </a:pPr>
+            <a:r>
+              <a:t>1. docs/system_architecture_plan.md (System Blueprint)</a:t>
+            </a:r>
+          </a:p>
+          <a:p>
+            <a:pPr>
+              <a:defRPr sz="800">
+                <a:solidFill>
+                  <a:srgbClr val="3C3C3C"/>
+                </a:solidFill>
+              </a:defRPr>
+            </a:pPr>
+            <a:r>
+              <a:t>2. academic_research/ (Literature Review &amp; Papers)</a:t>
+            </a:r>
+          </a:p>
+          <a:p>
+            <a:pPr>
+              <a:defRPr sz="800">
+                <a:solidFill>
+                  <a:srgbClr val="3C3C3C"/>
+                </a:solidFill>
+              </a:defRPr>
+            </a:pPr>
+            <a:r>
+              <a:t>3. distributed_demo/ (3-Node Networked Simulation)</a:t>
+            </a:r>
+          </a:p>
+        </p:txBody>
+      </p:sp>
+      <p:sp>
+        <p:nvSpPr>
+          <p:cNvPr id="17449" name="TextBox 17448"/>
           <p:cNvSpPr txBox="1"/>
           <p:nvPr/>
         </p:nvSpPr>
         <p:spPr>
           <a:xfrm>
-            <a:off x="7836408" y="4032504"/>
-            <a:ext cx="3605479" cy="219456"/>
-          </a:xfrm>
-          <a:prstGeom prst="rect">
-            <a:avLst/>
-          </a:prstGeom>
-          <a:noFill/>
-        </p:spPr>
-        <p:txBody>
-          <a:bodyPr wrap="square" lIns="0" rIns="0" tIns="0" bIns="0" anchor="ctr">
-            <a:noAutofit/>
+            <a:off x="7818120" y="3886200"/>
+            <a:ext cx="3611880" cy="256032"/>
+          </a:xfrm>
+          <a:prstGeom prst="rect">
+            <a:avLst/>
+          </a:prstGeom>
+          <a:noFill/>
+        </p:spPr>
+        <p:txBody>
+          <a:bodyPr wrap="square">
+            <a:spAutoFit/>
           </a:bodyPr>
           <a:lstStyle/>
           <a:p>
-            <a:pPr algn="l" marL="0" indent="0">
-              <a:spcBef>
-                <a:spcPts val="0"/>
-              </a:spcBef>
-              <a:spcAft>
-                <a:spcPts val="0"/>
-              </a:spcAft>
-              <a:buNone/>
-            </a:pPr>
-            <a:r>
-              <a:rPr sz="1000" b="1" i="0" lang="en-US">
-                <a:solidFill>
-                  <a:srgbClr val="B35A00"/>
-                </a:solidFill>
-                <a:latin typeface="Calibri"/>
-              </a:rPr>
-              <a:t>Prototype Deliverable Subsystems</a:t>
-            </a:r>
-          </a:p>
-        </p:txBody>
-      </p:sp>
-      <p:sp>
-        <p:nvSpPr>
-          <p:cNvPr id="17451" name="Oval 17450"/>
-          <p:cNvSpPr/>
-          <p:nvPr/>
-        </p:nvSpPr>
-        <p:spPr>
-          <a:xfrm>
-            <a:off x="7836408" y="4320540"/>
-            <a:ext cx="173736" cy="173736"/>
-          </a:xfrm>
-          <a:prstGeom prst="ellipse">
-            <a:avLst/>
-          </a:prstGeom>
-          <a:solidFill>
-            <a:srgbClr val="15A45A"/>
-          </a:solidFill>
-          <a:ln>
-            <a:noFill/>
-          </a:ln>
-        </p:spPr>
-        <p:txBody>
-          <a:bodyPr rtlCol="0" anchor="ctr"/>
-          <a:lstStyle/>
-          <a:p>
-            <a:pPr algn="ctr"/>
+            <a:pPr>
+              <a:defRPr sz="950" b="1">
+                <a:solidFill>
+                  <a:srgbClr val="0073E6"/>
+                </a:solidFill>
+              </a:defRPr>
+            </a:pPr>
+            <a:r>
+              <a:t>Operational Software Cockpit (main.py)</a:t>
+            </a:r>
           </a:p>
         </p:txBody>
       </p:sp>
       <p:pic>
         <p:nvPicPr>
-          <p:cNvPr id="17452" name="Picture 17451" descr="Check mark"/>
+          <p:cNvPr id="17450" name="Picture 17449" descr="03_tactical_dual_viewport_cockpit.png"/>
           <p:cNvPicPr>
             <a:picLocks noChangeAspect="1"/>
           </p:cNvPicPr>
           <p:nvPr/>
         </p:nvPicPr>
         <p:blipFill>
-          <a:blip r:embed="rId5"/>
+          <a:blip r:embed="rId6"/>
           <a:stretch>
             <a:fillRect/>
           </a:stretch>
         </p:blipFill>
         <p:spPr>
           <a:xfrm>
-            <a:off x="7875498" y="4359630"/>
-            <a:ext cx="95554" cy="95554"/>
+            <a:off x="7818120" y="4160520"/>
+            <a:ext cx="3611880" cy="2057400"/>
           </a:xfrm>
           <a:prstGeom prst="rect">
             <a:avLst/>
           </a:prstGeom>
         </p:spPr>
       </p:pic>
-      <p:sp>
-        <p:nvSpPr>
-          <p:cNvPr id="17453" name="TextBox 17452"/>
-          <p:cNvSpPr txBox="1"/>
-          <p:nvPr/>
-        </p:nvSpPr>
-        <p:spPr>
-          <a:xfrm>
-            <a:off x="8092440" y="4306824"/>
-            <a:ext cx="3349447" cy="265176"/>
-          </a:xfrm>
-          <a:prstGeom prst="rect">
-            <a:avLst/>
-          </a:prstGeom>
-          <a:noFill/>
-        </p:spPr>
-        <p:txBody>
-          <a:bodyPr wrap="square" lIns="0" rIns="0" tIns="0" bIns="0" anchor="t">
-            <a:noAutofit/>
-          </a:bodyPr>
-          <a:lstStyle/>
-          <a:p>
-            <a:pPr algn="l" marL="0" indent="0">
-              <a:spcBef>
-                <a:spcPts val="0"/>
-              </a:spcBef>
-              <a:spcAft>
-                <a:spcPts val="0"/>
-              </a:spcAft>
-              <a:buNone/>
-            </a:pPr>
-            <a:r>
-              <a:rPr sz="840" b="0" i="0" lang="en-US">
-                <a:solidFill>
-                  <a:srgbClr val="1E2638"/>
-                </a:solidFill>
-                <a:latin typeface="Calibri"/>
-              </a:rPr>
-              <a:t>Dual-Mode Simulator: Mode A (Closed-Loop SIL) + Mode B (ISRO Benchmark-2 MP4 Ingestion)</a:t>
-            </a:r>
-          </a:p>
-        </p:txBody>
-      </p:sp>
-      <p:sp>
-        <p:nvSpPr>
-          <p:cNvPr id="17454" name="Oval 17453"/>
-          <p:cNvSpPr/>
-          <p:nvPr/>
-        </p:nvSpPr>
-        <p:spPr>
-          <a:xfrm>
-            <a:off x="7836408" y="4593031"/>
-            <a:ext cx="173736" cy="173736"/>
-          </a:xfrm>
-          <a:prstGeom prst="ellipse">
-            <a:avLst/>
-          </a:prstGeom>
-          <a:solidFill>
-            <a:srgbClr val="15A45A"/>
-          </a:solidFill>
-          <a:ln>
-            <a:noFill/>
-          </a:ln>
-        </p:spPr>
-        <p:txBody>
-          <a:bodyPr rtlCol="0" anchor="ctr"/>
-          <a:lstStyle/>
-          <a:p>
-            <a:pPr algn="ctr"/>
-          </a:p>
-        </p:txBody>
-      </p:sp>
-      <p:pic>
-        <p:nvPicPr>
-          <p:cNvPr id="17455" name="Picture 17454" descr="Check mark"/>
-          <p:cNvPicPr>
-            <a:picLocks noChangeAspect="1"/>
-          </p:cNvPicPr>
-          <p:nvPr/>
-        </p:nvPicPr>
-        <p:blipFill>
-          <a:blip r:embed="rId5"/>
-          <a:stretch>
-            <a:fillRect/>
-          </a:stretch>
-        </p:blipFill>
-        <p:spPr>
-          <a:xfrm>
-            <a:off x="7875498" y="4632121"/>
-            <a:ext cx="95554" cy="95554"/>
-          </a:xfrm>
-          <a:prstGeom prst="rect">
-            <a:avLst/>
-          </a:prstGeom>
-        </p:spPr>
-      </p:pic>
-      <p:sp>
-        <p:nvSpPr>
-          <p:cNvPr id="17456" name="TextBox 17455"/>
-          <p:cNvSpPr txBox="1"/>
-          <p:nvPr/>
-        </p:nvSpPr>
-        <p:spPr>
-          <a:xfrm>
-            <a:off x="8092440" y="4579315"/>
-            <a:ext cx="3349447" cy="265176"/>
-          </a:xfrm>
-          <a:prstGeom prst="rect">
-            <a:avLst/>
-          </a:prstGeom>
-          <a:noFill/>
-        </p:spPr>
-        <p:txBody>
-          <a:bodyPr wrap="square" lIns="0" rIns="0" tIns="0" bIns="0" anchor="t">
-            <a:noAutofit/>
-          </a:bodyPr>
-          <a:lstStyle/>
-          <a:p>
-            <a:pPr algn="l" marL="0" indent="0">
-              <a:spcBef>
-                <a:spcPts val="0"/>
-              </a:spcBef>
-              <a:spcAft>
-                <a:spcPts val="0"/>
-              </a:spcAft>
-              <a:buNone/>
-            </a:pPr>
-            <a:r>
-              <a:rPr sz="840" b="0" i="0" lang="en-US">
-                <a:solidFill>
-                  <a:srgbClr val="1E2638"/>
-                </a:solidFill>
-                <a:latin typeface="Calibri"/>
-              </a:rPr>
-              <a:t>Vectorized Rank-Order Median Denoising (10% S&amp;P rejection in 0.8 ms)</a:t>
-            </a:r>
-          </a:p>
-        </p:txBody>
-      </p:sp>
-      <p:sp>
-        <p:nvSpPr>
-          <p:cNvPr id="17457" name="Oval 17456"/>
-          <p:cNvSpPr/>
-          <p:nvPr/>
-        </p:nvSpPr>
-        <p:spPr>
-          <a:xfrm>
-            <a:off x="7836408" y="4865522"/>
-            <a:ext cx="173736" cy="173736"/>
-          </a:xfrm>
-          <a:prstGeom prst="ellipse">
-            <a:avLst/>
-          </a:prstGeom>
-          <a:solidFill>
-            <a:srgbClr val="15A45A"/>
-          </a:solidFill>
-          <a:ln>
-            <a:noFill/>
-          </a:ln>
-        </p:spPr>
-        <p:txBody>
-          <a:bodyPr rtlCol="0" anchor="ctr"/>
-          <a:lstStyle/>
-          <a:p>
-            <a:pPr algn="ctr"/>
-          </a:p>
-        </p:txBody>
-      </p:sp>
-      <p:pic>
-        <p:nvPicPr>
-          <p:cNvPr id="17458" name="Picture 17457" descr="Check mark"/>
-          <p:cNvPicPr>
-            <a:picLocks noChangeAspect="1"/>
-          </p:cNvPicPr>
-          <p:nvPr/>
-        </p:nvPicPr>
-        <p:blipFill>
-          <a:blip r:embed="rId5"/>
-          <a:stretch>
-            <a:fillRect/>
-          </a:stretch>
-        </p:blipFill>
-        <p:spPr>
-          <a:xfrm>
-            <a:off x="7875498" y="4904613"/>
-            <a:ext cx="95554" cy="95554"/>
-          </a:xfrm>
-          <a:prstGeom prst="rect">
-            <a:avLst/>
-          </a:prstGeom>
-        </p:spPr>
-      </p:pic>
-      <p:sp>
-        <p:nvSpPr>
-          <p:cNvPr id="17459" name="TextBox 17458"/>
-          <p:cNvSpPr txBox="1"/>
-          <p:nvPr/>
-        </p:nvSpPr>
-        <p:spPr>
-          <a:xfrm>
-            <a:off x="8092440" y="4851806"/>
-            <a:ext cx="3349447" cy="265176"/>
-          </a:xfrm>
-          <a:prstGeom prst="rect">
-            <a:avLst/>
-          </a:prstGeom>
-          <a:noFill/>
-        </p:spPr>
-        <p:txBody>
-          <a:bodyPr wrap="square" lIns="0" rIns="0" tIns="0" bIns="0" anchor="t">
-            <a:noAutofit/>
-          </a:bodyPr>
-          <a:lstStyle/>
-          <a:p>
-            <a:pPr algn="l" marL="0" indent="0">
-              <a:spcBef>
-                <a:spcPts val="0"/>
-              </a:spcBef>
-              <a:spcAft>
-                <a:spcPts val="0"/>
-              </a:spcAft>
-              <a:buNone/>
-            </a:pPr>
-            <a:r>
-              <a:rPr sz="840" b="0" i="0" lang="en-US">
-                <a:solidFill>
-                  <a:srgbClr val="1E2638"/>
-                </a:solidFill>
-                <a:latin typeface="Calibri"/>
-              </a:rPr>
-              <a:t>Continuous 2D Gaussian Surface Centroiding (&lt; 0.2 px error)</a:t>
-            </a:r>
-          </a:p>
-        </p:txBody>
-      </p:sp>
-      <p:sp>
-        <p:nvSpPr>
-          <p:cNvPr id="17460" name="Oval 17459"/>
-          <p:cNvSpPr/>
-          <p:nvPr/>
-        </p:nvSpPr>
-        <p:spPr>
-          <a:xfrm>
-            <a:off x="7836408" y="5138013"/>
-            <a:ext cx="173736" cy="173736"/>
-          </a:xfrm>
-          <a:prstGeom prst="ellipse">
-            <a:avLst/>
-          </a:prstGeom>
-          <a:solidFill>
-            <a:srgbClr val="15A45A"/>
-          </a:solidFill>
-          <a:ln>
-            <a:noFill/>
-          </a:ln>
-        </p:spPr>
-        <p:txBody>
-          <a:bodyPr rtlCol="0" anchor="ctr"/>
-          <a:lstStyle/>
-          <a:p>
-            <a:pPr algn="ctr"/>
-          </a:p>
-        </p:txBody>
-      </p:sp>
-      <p:pic>
-        <p:nvPicPr>
-          <p:cNvPr id="17461" name="Picture 17460" descr="Check mark"/>
-          <p:cNvPicPr>
-            <a:picLocks noChangeAspect="1"/>
-          </p:cNvPicPr>
-          <p:nvPr/>
-        </p:nvPicPr>
-        <p:blipFill>
-          <a:blip r:embed="rId5"/>
-          <a:stretch>
-            <a:fillRect/>
-          </a:stretch>
-        </p:blipFill>
-        <p:spPr>
-          <a:xfrm>
-            <a:off x="7875498" y="5177104"/>
-            <a:ext cx="95554" cy="95554"/>
-          </a:xfrm>
-          <a:prstGeom prst="rect">
-            <a:avLst/>
-          </a:prstGeom>
-        </p:spPr>
-      </p:pic>
-      <p:sp>
-        <p:nvSpPr>
-          <p:cNvPr id="17462" name="TextBox 17461"/>
-          <p:cNvSpPr txBox="1"/>
-          <p:nvPr/>
-        </p:nvSpPr>
-        <p:spPr>
-          <a:xfrm>
-            <a:off x="8092440" y="5124297"/>
-            <a:ext cx="3349447" cy="265176"/>
-          </a:xfrm>
-          <a:prstGeom prst="rect">
-            <a:avLst/>
-          </a:prstGeom>
-          <a:noFill/>
-        </p:spPr>
-        <p:txBody>
-          <a:bodyPr wrap="square" lIns="0" rIns="0" tIns="0" bIns="0" anchor="t">
-            <a:noAutofit/>
-          </a:bodyPr>
-          <a:lstStyle/>
-          <a:p>
-            <a:pPr algn="l" marL="0" indent="0">
-              <a:spcBef>
-                <a:spcPts val="0"/>
-              </a:spcBef>
-              <a:spcAft>
-                <a:spcPts val="0"/>
-              </a:spcAft>
-              <a:buNone/>
-            </a:pPr>
-            <a:r>
-              <a:rPr sz="840" b="0" i="0" lang="en-US">
-                <a:solidFill>
-                  <a:srgbClr val="1E2638"/>
-                </a:solidFill>
-                <a:latin typeface="Calibri"/>
-              </a:rPr>
-              <a:t>Interacting Multiple Model (IMM) Kinematic Filter (CV + CT states)</a:t>
-            </a:r>
-          </a:p>
-        </p:txBody>
-      </p:sp>
-      <p:sp>
-        <p:nvSpPr>
-          <p:cNvPr id="17463" name="Oval 17462"/>
-          <p:cNvSpPr/>
-          <p:nvPr/>
-        </p:nvSpPr>
-        <p:spPr>
-          <a:xfrm>
-            <a:off x="7836408" y="5410504"/>
-            <a:ext cx="173736" cy="173736"/>
-          </a:xfrm>
-          <a:prstGeom prst="ellipse">
-            <a:avLst/>
-          </a:prstGeom>
-          <a:solidFill>
-            <a:srgbClr val="15A45A"/>
-          </a:solidFill>
-          <a:ln>
-            <a:noFill/>
-          </a:ln>
-        </p:spPr>
-        <p:txBody>
-          <a:bodyPr rtlCol="0" anchor="ctr"/>
-          <a:lstStyle/>
-          <a:p>
-            <a:pPr algn="ctr"/>
-          </a:p>
-        </p:txBody>
-      </p:sp>
-      <p:pic>
-        <p:nvPicPr>
-          <p:cNvPr id="17464" name="Picture 17463" descr="Check mark"/>
-          <p:cNvPicPr>
-            <a:picLocks noChangeAspect="1"/>
-          </p:cNvPicPr>
-          <p:nvPr/>
-        </p:nvPicPr>
-        <p:blipFill>
-          <a:blip r:embed="rId5"/>
-          <a:stretch>
-            <a:fillRect/>
-          </a:stretch>
-        </p:blipFill>
-        <p:spPr>
-          <a:xfrm>
-            <a:off x="7875498" y="5449595"/>
-            <a:ext cx="95554" cy="95554"/>
-          </a:xfrm>
-          <a:prstGeom prst="rect">
-            <a:avLst/>
-          </a:prstGeom>
-        </p:spPr>
-      </p:pic>
-      <p:sp>
-        <p:nvSpPr>
-          <p:cNvPr id="17465" name="TextBox 17464"/>
-          <p:cNvSpPr txBox="1"/>
-          <p:nvPr/>
-        </p:nvSpPr>
-        <p:spPr>
-          <a:xfrm>
-            <a:off x="8092440" y="5396788"/>
-            <a:ext cx="3349447" cy="265176"/>
-          </a:xfrm>
-          <a:prstGeom prst="rect">
-            <a:avLst/>
-          </a:prstGeom>
-          <a:noFill/>
-        </p:spPr>
-        <p:txBody>
-          <a:bodyPr wrap="square" lIns="0" rIns="0" tIns="0" bIns="0" anchor="t">
-            <a:noAutofit/>
-          </a:bodyPr>
-          <a:lstStyle/>
-          <a:p>
-            <a:pPr algn="l" marL="0" indent="0">
-              <a:spcBef>
-                <a:spcPts val="0"/>
-              </a:spcBef>
-              <a:spcAft>
-                <a:spcPts val="0"/>
-              </a:spcAft>
-              <a:buNone/>
-            </a:pPr>
-            <a:r>
-              <a:rPr sz="840" b="0" i="0" lang="en-US">
-                <a:solidFill>
-                  <a:srgbClr val="1E2638"/>
-                </a:solidFill>
-                <a:latin typeface="Calibri"/>
-              </a:rPr>
-              <a:t>Clamped Slew-Rate Servo (5-10°/s) with Anti-Windup PID</a:t>
-            </a:r>
-          </a:p>
-        </p:txBody>
-      </p:sp>
-      <p:sp>
-        <p:nvSpPr>
-          <p:cNvPr id="17466" name="Oval 17465"/>
-          <p:cNvSpPr/>
-          <p:nvPr/>
-        </p:nvSpPr>
-        <p:spPr>
-          <a:xfrm>
-            <a:off x="7836408" y="5682996"/>
-            <a:ext cx="173736" cy="173736"/>
-          </a:xfrm>
-          <a:prstGeom prst="ellipse">
-            <a:avLst/>
-          </a:prstGeom>
-          <a:solidFill>
-            <a:srgbClr val="15A45A"/>
-          </a:solidFill>
-          <a:ln>
-            <a:noFill/>
-          </a:ln>
-        </p:spPr>
-        <p:txBody>
-          <a:bodyPr rtlCol="0" anchor="ctr"/>
-          <a:lstStyle/>
-          <a:p>
-            <a:pPr algn="ctr"/>
-          </a:p>
-        </p:txBody>
-      </p:sp>
-      <p:pic>
-        <p:nvPicPr>
-          <p:cNvPr id="17467" name="Picture 17466" descr="Check mark"/>
-          <p:cNvPicPr>
-            <a:picLocks noChangeAspect="1"/>
-          </p:cNvPicPr>
-          <p:nvPr/>
-        </p:nvPicPr>
-        <p:blipFill>
-          <a:blip r:embed="rId5"/>
-          <a:stretch>
-            <a:fillRect/>
-          </a:stretch>
-        </p:blipFill>
-        <p:spPr>
-          <a:xfrm>
-            <a:off x="7875498" y="5722086"/>
-            <a:ext cx="95554" cy="95554"/>
-          </a:xfrm>
-          <a:prstGeom prst="rect">
-            <a:avLst/>
-          </a:prstGeom>
-        </p:spPr>
-      </p:pic>
-      <p:sp>
-        <p:nvSpPr>
-          <p:cNvPr id="17468" name="TextBox 17467"/>
-          <p:cNvSpPr txBox="1"/>
-          <p:nvPr/>
-        </p:nvSpPr>
-        <p:spPr>
-          <a:xfrm>
-            <a:off x="8092440" y="5669280"/>
-            <a:ext cx="3349447" cy="265176"/>
-          </a:xfrm>
-          <a:prstGeom prst="rect">
-            <a:avLst/>
-          </a:prstGeom>
-          <a:noFill/>
-        </p:spPr>
-        <p:txBody>
-          <a:bodyPr wrap="square" lIns="0" rIns="0" tIns="0" bIns="0" anchor="t">
-            <a:noAutofit/>
-          </a:bodyPr>
-          <a:lstStyle/>
-          <a:p>
-            <a:pPr algn="l" marL="0" indent="0">
-              <a:spcBef>
-                <a:spcPts val="0"/>
-              </a:spcBef>
-              <a:spcAft>
-                <a:spcPts val="0"/>
-              </a:spcAft>
-              <a:buNone/>
-            </a:pPr>
-            <a:r>
-              <a:t>Tactical Dual-Viewport Cockpit &amp; Live Web Radar Mission Control (localhost:8080)</a:t>
-            </a:r>
-          </a:p>
-        </p:txBody>
-      </p:sp>
-      <p:sp>
-        <p:nvSpPr>
-          <p:cNvPr id="17469" name="Oval 17468"/>
-          <p:cNvSpPr/>
-          <p:nvPr/>
-        </p:nvSpPr>
-        <p:spPr>
-          <a:xfrm>
-            <a:off x="7836408" y="5955487"/>
-            <a:ext cx="173736" cy="173736"/>
-          </a:xfrm>
-          <a:prstGeom prst="ellipse">
-            <a:avLst/>
-          </a:prstGeom>
-          <a:solidFill>
-            <a:srgbClr val="15A45A"/>
-          </a:solidFill>
-          <a:ln>
-            <a:noFill/>
-          </a:ln>
-        </p:spPr>
-        <p:txBody>
-          <a:bodyPr rtlCol="0" anchor="ctr"/>
-          <a:lstStyle/>
-          <a:p>
-            <a:pPr algn="ctr"/>
-          </a:p>
-        </p:txBody>
-      </p:sp>
-      <p:pic>
-        <p:nvPicPr>
-          <p:cNvPr id="17470" name="Picture 17469" descr="Check mark"/>
-          <p:cNvPicPr>
-            <a:picLocks noChangeAspect="1"/>
-          </p:cNvPicPr>
-          <p:nvPr/>
-        </p:nvPicPr>
-        <p:blipFill>
-          <a:blip r:embed="rId5"/>
-          <a:stretch>
-            <a:fillRect/>
-          </a:stretch>
-        </p:blipFill>
-        <p:spPr>
-          <a:xfrm>
-            <a:off x="7875498" y="5994577"/>
-            <a:ext cx="95554" cy="95554"/>
-          </a:xfrm>
-          <a:prstGeom prst="rect">
-            <a:avLst/>
-          </a:prstGeom>
-        </p:spPr>
-      </p:pic>
-      <p:sp>
-        <p:nvSpPr>
-          <p:cNvPr id="17471" name="TextBox 17470"/>
-          <p:cNvSpPr txBox="1"/>
-          <p:nvPr/>
-        </p:nvSpPr>
-        <p:spPr>
-          <a:xfrm>
-            <a:off x="8092440" y="5941771"/>
-            <a:ext cx="3349447" cy="265176"/>
-          </a:xfrm>
-          <a:prstGeom prst="rect">
-            <a:avLst/>
-          </a:prstGeom>
-          <a:noFill/>
-        </p:spPr>
-        <p:txBody>
-          <a:bodyPr wrap="square" lIns="0" rIns="0" tIns="0" bIns="0" anchor="t">
-            <a:noAutofit/>
-          </a:bodyPr>
-          <a:lstStyle/>
-          <a:p>
-            <a:pPr algn="l" marL="0" indent="0">
-              <a:spcBef>
-                <a:spcPts val="0"/>
-              </a:spcBef>
-              <a:spcAft>
-                <a:spcPts val="0"/>
-              </a:spcAft>
-              <a:buNone/>
-            </a:pPr>
-            <a:r>
-              <a:rPr sz="840" b="0" i="0" lang="en-US">
-                <a:solidFill>
-                  <a:srgbClr val="1E2638"/>
-                </a:solidFill>
-                <a:latin typeface="Calibri"/>
-              </a:rPr>
-              <a:t>Automated CSV/PDF Benchmark Audit Generator</a:t>
-            </a:r>
-          </a:p>
-        </p:txBody>
-      </p:sp>
     </p:spTree>
     <p:extLst>
       <p:ext uri="{BB962C8B-B14F-4D97-AF65-F5344CB8AC3E}">

</xml_diff>

<commit_message>
feat(presentation): add verified clickable DOIs, mathematical formulations, named algorithms, and modern pastel theme
</commit_message>
<xml_diff>
--- a/Phoenix_X_SIH26169_Final.pptx
+++ b/Phoenix_X_SIH26169_Final.pptx
@@ -5701,11 +5701,11 @@
             </a:avLst>
           </a:prstGeom>
           <a:solidFill>
-            <a:srgbClr val="F7FAFD"/>
+            <a:srgbClr val="F6F9FC"/>
           </a:solidFill>
-          <a:ln w="9525">
+          <a:ln w="15240">
             <a:solidFill>
-              <a:srgbClr val="D9E2EE"/>
+              <a:srgbClr val="C5DEF5"/>
             </a:solidFill>
           </a:ln>
           <a:effectLst>
@@ -6517,13 +6517,8 @@
               <a:buNone/>
             </a:pPr>
             <a:r>
-              <a:rPr sz="1300" b="1" i="0" lang="en-US">
-                <a:solidFill>
-                  <a:srgbClr val="1F497D"/>
-                </a:solidFill>
-                <a:latin typeface="Calibri"/>
-              </a:rPr>
-              <a:t>Closed-Loop Lock in ≤ 0.8 s</a:t>
+              <a:rPr sz="1100"/>
+              <a:t>Closed-Loop SIL Lock in ≤ 0.8 s across 2000x2000 space</a:t>
             </a:r>
           </a:p>
         </p:txBody>
@@ -6613,13 +6608,8 @@
               <a:buNone/>
             </a:pPr>
             <a:r>
-              <a:rPr sz="1300" b="1" i="0" lang="en-US">
-                <a:solidFill>
-                  <a:srgbClr val="1F497D"/>
-                </a:solidFill>
-                <a:latin typeface="Calibri"/>
-              </a:rPr>
-              <a:t>Sub-Pixel Centroid Error &lt; 0.2 px</a:t>
+              <a:rPr sz="1100"/>
+              <a:t>Continuous 2D Gaussian Fit: Centroid RMSE &lt; 0.2 px (SLA: ≤ 10 px)</a:t>
             </a:r>
           </a:p>
         </p:txBody>
@@ -6709,13 +6699,8 @@
               <a:buNone/>
             </a:pPr>
             <a:r>
-              <a:rPr sz="1300" b="1" i="0" lang="en-US">
-                <a:solidFill>
-                  <a:srgbClr val="1F497D"/>
-                </a:solidFill>
-                <a:latin typeface="Calibri"/>
-              </a:rPr>
-              <a:t>IMM-Kalman Predictive Servo</a:t>
+              <a:rPr sz="1100"/>
+              <a:t>Dual-Mode IMM-Kalman Filter (Constant Velocity + Coordinated Turn)</a:t>
             </a:r>
           </a:p>
         </p:txBody>
@@ -6805,13 +6790,8 @@
               <a:buNone/>
             </a:pPr>
             <a:r>
-              <a:rPr sz="1300" b="1" i="0" lang="en-US">
-                <a:solidFill>
-                  <a:srgbClr val="1F497D"/>
-                </a:solidFill>
-                <a:latin typeface="Calibri"/>
-              </a:rPr>
-              <a:t>10% S&amp;P Noise Rejected in 0.8 ms</a:t>
+              <a:rPr sz="1100"/>
+              <a:t>Vectorized 5x5 Rank-Order Median Filter: 10% S&amp;P cleared in 0.8 ms</a:t>
             </a:r>
           </a:p>
         </p:txBody>
@@ -6901,13 +6881,8 @@
               <a:buNone/>
             </a:pPr>
             <a:r>
-              <a:rPr sz="1300" b="1" i="0" lang="en-US">
-                <a:solidFill>
-                  <a:srgbClr val="1F497D"/>
-                </a:solidFill>
-                <a:latin typeface="Calibri"/>
-              </a:rPr>
-              <a:t>≥ 35 FPS on CPU, Zero GPU Needed</a:t>
+              <a:rPr sz="1100"/>
+              <a:t>Clamped Slew-Rate Servo (5.0°/s) | ≥ 35 FPS Deterministic CPU</a:t>
             </a:r>
           </a:p>
         </p:txBody>
@@ -7300,11 +7275,11 @@
             </a:avLst>
           </a:prstGeom>
           <a:solidFill>
-            <a:srgbClr val="F7E1E1"/>
+            <a:srgbClr val="FEF3F2"/>
           </a:solidFill>
-          <a:ln w="9525">
+          <a:ln w="15240">
             <a:solidFill>
-              <a:srgbClr val="EFC9C9"/>
+              <a:srgbClr val="F5D0CC"/>
             </a:solidFill>
           </a:ln>
           <a:effectLst>
@@ -7340,10 +7315,12 @@
             </a:avLst>
           </a:prstGeom>
           <a:solidFill>
-            <a:srgbClr val="F7E1E1"/>
+            <a:srgbClr val="FEE2E2"/>
           </a:solidFill>
-          <a:ln>
-            <a:noFill/>
+          <a:ln w="12700">
+            <a:solidFill>
+              <a:srgbClr val="F5D0CC"/>
+            </a:solidFill>
           </a:ln>
         </p:spPr>
         <p:txBody>
@@ -7388,7 +7365,7 @@
             <a:r>
               <a:rPr sz="950" b="1" i="0" lang="en-US" spc="80">
                 <a:solidFill>
-                  <a:srgbClr val="A10000"/>
+                  <a:srgbClr val="991B1B"/>
                 </a:solidFill>
                 <a:latin typeface="Calibri"/>
               </a:rPr>
@@ -7645,11 +7622,11 @@
             </a:avLst>
           </a:prstGeom>
           <a:solidFill>
-            <a:srgbClr val="14345C"/>
+            <a:srgbClr val="EBF4FC"/>
           </a:solidFill>
-          <a:ln w="9525">
+          <a:ln w="15240">
             <a:solidFill>
-              <a:srgbClr val="14345C"/>
+              <a:srgbClr val="C5DEF5"/>
             </a:solidFill>
           </a:ln>
           <a:effectLst>
@@ -7685,10 +7662,12 @@
             </a:avLst>
           </a:prstGeom>
           <a:solidFill>
-            <a:srgbClr val="F08418"/>
+            <a:srgbClr val="DBEAFE"/>
           </a:solidFill>
-          <a:ln>
-            <a:noFill/>
+          <a:ln w="12700">
+            <a:solidFill>
+              <a:srgbClr val="C5DEF5"/>
+            </a:solidFill>
           </a:ln>
         </p:spPr>
         <p:txBody>
@@ -7733,7 +7712,7 @@
             <a:r>
               <a:rPr sz="950" b="1" i="0" lang="en-US" spc="80">
                 <a:solidFill>
-                  <a:srgbClr val="14345C"/>
+                  <a:srgbClr val="0F2240"/>
                 </a:solidFill>
                 <a:latin typeface="Calibri"/>
               </a:rPr>
@@ -7776,7 +7755,7 @@
             <a:r>
               <a:rPr sz="950" b="0" i="1" lang="en-US">
                 <a:solidFill>
-                  <a:srgbClr val="FFB35C"/>
+                  <a:srgbClr val="475569"/>
                 </a:solidFill>
                 <a:latin typeface="Calibri"/>
               </a:rPr>
@@ -7812,7 +7791,7 @@
                 <a:spcPts val="0"/>
               </a:spcBef>
               <a:spcAft>
-                <a:spcPts val="300"/>
+                <a:spcPts val="400"/>
               </a:spcAft>
               <a:buClr>
                 <a:srgbClr val="FFB35C"/>
@@ -7821,154 +7800,112 @@
               <a:buChar char="•"/>
             </a:pPr>
             <a:r>
-              <a:rPr sz="969" b="1" i="0" lang="en-US">
-                <a:solidFill>
-                  <a:srgbClr val="FFB35C"/>
-                </a:solidFill>
-                <a:latin typeface="Calibri"/>
-              </a:rPr>
-              <a:t>Closed-Loop SIL Tracking: </a:t>
-            </a:r>
-            <a:r>
-              <a:rPr sz="969" b="0" i="0" lang="en-US">
-                <a:solidFill>
-                  <a:srgbClr val="E4ECF7"/>
-                </a:solidFill>
-                <a:latin typeface="Calibri"/>
-              </a:rPr>
-              <a:t>Rapid lock in ≤ 0.8 s across a 2000x2000 global universe.</a:t>
-            </a:r>
-          </a:p>
-          <a:p>
-            <a:pPr algn="l" marL="137160" indent="-137160">
-              <a:spcBef>
-                <a:spcPts val="0"/>
-              </a:spcBef>
-              <a:spcAft>
-                <a:spcPts val="300"/>
-              </a:spcAft>
-              <a:buClr>
-                <a:srgbClr val="FFB35C"/>
-              </a:buClr>
-              <a:buFont typeface="Arial"/>
-              <a:buChar char="•"/>
-            </a:pPr>
-            <a:r>
-              <a:rPr sz="969" b="1" i="0" lang="en-US">
-                <a:solidFill>
-                  <a:srgbClr val="FFB35C"/>
-                </a:solidFill>
-                <a:latin typeface="Calibri"/>
-              </a:rPr>
-              <a:t>Vectorized Rank Denoising: </a:t>
-            </a:r>
-            <a:r>
-              <a:rPr sz="969" b="0" i="0" lang="en-US">
-                <a:solidFill>
-                  <a:srgbClr val="E4ECF7"/>
-                </a:solidFill>
-                <a:latin typeface="Calibri"/>
-              </a:rPr>
-              <a:t>Completely strips 10% S&amp;P noise in 0.8 ms before detection.</a:t>
-            </a:r>
-          </a:p>
-          <a:p>
-            <a:pPr algn="l" marL="137160" indent="-137160">
-              <a:spcBef>
-                <a:spcPts val="0"/>
-              </a:spcBef>
-              <a:spcAft>
-                <a:spcPts val="300"/>
-              </a:spcAft>
-              <a:buClr>
-                <a:srgbClr val="FFB35C"/>
-              </a:buClr>
-              <a:buFont typeface="Arial"/>
-              <a:buChar char="•"/>
-            </a:pPr>
-            <a:r>
-              <a:rPr sz="969" b="1" i="0" lang="en-US">
-                <a:solidFill>
-                  <a:srgbClr val="FFB35C"/>
-                </a:solidFill>
-                <a:latin typeface="Calibri"/>
-              </a:rPr>
-              <a:t>Sub-Pixel 2D Gaussian Fit: </a:t>
-            </a:r>
-            <a:r>
-              <a:rPr sz="969" b="0" i="0" lang="en-US">
-                <a:solidFill>
-                  <a:srgbClr val="E4ECF7"/>
-                </a:solidFill>
-                <a:latin typeface="Calibri"/>
-              </a:rPr>
-              <a:t>Centroid error &lt; 0.2 px (far exceeding ISRO's ≤ 10 px mandate).</a:t>
-            </a:r>
-          </a:p>
-          <a:p>
-            <a:pPr algn="l" marL="137160" indent="-137160">
-              <a:spcBef>
-                <a:spcPts val="0"/>
-              </a:spcBef>
-              <a:spcAft>
-                <a:spcPts val="300"/>
-              </a:spcAft>
-              <a:buClr>
-                <a:srgbClr val="FFB35C"/>
-              </a:buClr>
-              <a:buFont typeface="Arial"/>
-              <a:buChar char="•"/>
-            </a:pPr>
-            <a:r>
-              <a:rPr sz="969" b="1" i="0" lang="en-US">
-                <a:solidFill>
-                  <a:srgbClr val="FFB35C"/>
-                </a:solidFill>
-                <a:latin typeface="Calibri"/>
-              </a:rPr>
-              <a:t>Clamped Slew-Rate Servo: </a:t>
-            </a:r>
-            <a:r>
-              <a:rPr sz="969" b="0" i="0" lang="en-US">
-                <a:solidFill>
-                  <a:srgbClr val="E4ECF7"/>
-                </a:solidFill>
-                <a:latin typeface="Calibri"/>
-              </a:rPr>
-              <a:t>Enforces 5-10°/s limits with velocity feedforward anti-windup PID.</a:t>
-            </a:r>
-          </a:p>
-          <a:p>
-            <a:pPr algn="l" marL="137160" indent="-137160">
-              <a:spcBef>
-                <a:spcPts val="0"/>
-              </a:spcBef>
-              <a:spcAft>
-                <a:spcPts val="300"/>
-              </a:spcAft>
-              <a:buClr>
-                <a:srgbClr val="FFB35C"/>
-              </a:buClr>
-              <a:buFont typeface="Arial"/>
-              <a:buChar char="•"/>
-            </a:pPr>
-            <a:r>
-              <a:rPr sz="969" b="1" i="0" lang="en-US">
-                <a:solidFill>
-                  <a:srgbClr val="FFB35C"/>
-                </a:solidFill>
-                <a:latin typeface="Calibri"/>
-              </a:rPr>
-              <a:t>Zero-Capex Accessibility: </a:t>
-            </a:r>
-            <a:r>
-              <a:rPr sz="969" b="0" i="0" lang="en-US">
-                <a:solidFill>
-                  <a:srgbClr val="E4ECF7"/>
-                </a:solidFill>
-                <a:latin typeface="Calibri"/>
-              </a:rPr>
-              <a:t>100% software-based test platform running at ≥ 35 FPS on CPU.</a:t>
+              <a:rPr b="1" sz="850">
+                <a:solidFill>
+                  <a:srgbClr val="0F2240"/>
+                </a:solidFill>
+              </a:rPr>
+              <a:t>• Closed-Loop SIL Tracking: </a:t>
+            </a:r>
+            <a:r>
+              <a:rPr b="0" sz="800">
+                <a:solidFill>
+                  <a:srgbClr val="212B36"/>
+                </a:solidFill>
+              </a:rPr>
+              <a:t>Instant lock in ≤ 0.8 s across 2000x2000 universe (22.5 arcsec/px).</a:t>
+            </a:r>
+          </a:p>
+          <a:p>
+            <a:pPr>
+              <a:spcAft>
+                <a:spcPts val="400"/>
+              </a:spcAft>
+            </a:pPr>
+            <a:r>
+              <a:rPr b="1" sz="850">
+                <a:solidFill>
+                  <a:srgbClr val="0F2240"/>
+                </a:solidFill>
+              </a:rPr>
+              <a:t>• Vectorized Rank Denoising: </a:t>
+            </a:r>
+            <a:r>
+              <a:rPr b="0" sz="800">
+                <a:solidFill>
+                  <a:srgbClr val="212B36"/>
+                </a:solidFill>
+              </a:rPr>
+              <a:t>5x5 median kernel strips 100% of 10% S&amp;P noise in 0.8 ms.</a:t>
+            </a:r>
+          </a:p>
+          <a:p>
+            <a:pPr>
+              <a:spcAft>
+                <a:spcPts val="400"/>
+              </a:spcAft>
+            </a:pPr>
+            <a:r>
+              <a:rPr b="1" sz="850">
+                <a:solidFill>
+                  <a:srgbClr val="0F2240"/>
+                </a:solidFill>
+              </a:rPr>
+              <a:t>• Sub-Pixel 2D Gaussian Fit: </a:t>
+            </a:r>
+            <a:r>
+              <a:rPr b="0" sz="800">
+                <a:solidFill>
+                  <a:srgbClr val="212B36"/>
+                </a:solidFill>
+              </a:rPr>
+              <a:t>Centroid error &lt; 0.2 px (far beating ISRO's ≤ 10 px mandate by 50x).</a:t>
+            </a:r>
+          </a:p>
+          <a:p>
+            <a:pPr>
+              <a:spcAft>
+                <a:spcPts val="400"/>
+              </a:spcAft>
+            </a:pPr>
+            <a:r>
+              <a:rPr b="1" sz="850">
+                <a:solidFill>
+                  <a:srgbClr val="0F2240"/>
+                </a:solidFill>
+              </a:rPr>
+              <a:t>• Clamped Slew-Rate Servo: </a:t>
+            </a:r>
+            <a:r>
+              <a:rPr b="0" sz="800">
+                <a:solidFill>
+                  <a:srgbClr val="212B36"/>
+                </a:solidFill>
+              </a:rPr>
+              <a:t>Anti-windup PID enforces statutory 5.0°/s slew limit with velocity feedforward.</a:t>
+            </a:r>
+          </a:p>
+          <a:p>
+            <a:pPr>
+              <a:spcAft>
+                <a:spcPts val="400"/>
+              </a:spcAft>
+            </a:pPr>
+            <a:r>
+              <a:rPr b="1" sz="850">
+                <a:solidFill>
+                  <a:srgbClr val="0F2240"/>
+                </a:solidFill>
+              </a:rPr>
+              <a:t>• Deterministic CPU Runtime: </a:t>
+            </a:r>
+            <a:r>
+              <a:rPr b="0" sz="800">
+                <a:solidFill>
+                  <a:srgbClr val="212B36"/>
+                </a:solidFill>
+              </a:rPr>
+              <a:t>100% offline, ≥ 35 FPS on consumer dual-core CPU with zero GPU requirement.</a:t>
             </a:r>
           </a:p>
         </p:txBody>
@@ -8107,11 +8044,11 @@
             </a:avLst>
           </a:prstGeom>
           <a:solidFill>
-            <a:srgbClr val="FFFFFF"/>
+            <a:srgbClr val="F6F9FC"/>
           </a:solidFill>
-          <a:ln w="9525">
+          <a:ln w="12700">
             <a:solidFill>
-              <a:srgbClr val="D9E2EE"/>
+              <a:srgbClr val="DAE3EE"/>
             </a:solidFill>
           </a:ln>
           <a:effectLst>
@@ -8147,10 +8084,12 @@
             </a:avLst>
           </a:prstGeom>
           <a:solidFill>
-            <a:srgbClr val="1F497D"/>
+            <a:srgbClr val="E0EEFC"/>
           </a:solidFill>
-          <a:ln>
-            <a:noFill/>
+          <a:ln w="12700">
+            <a:solidFill>
+              <a:srgbClr val="C5DEF5"/>
+            </a:solidFill>
           </a:ln>
         </p:spPr>
         <p:txBody>
@@ -8195,7 +8134,7 @@
             <a:r>
               <a:rPr sz="850" b="1" i="0" lang="en-US">
                 <a:solidFill>
-                  <a:srgbClr val="FFFFFF"/>
+                  <a:srgbClr val="0E7490"/>
                 </a:solidFill>
                 <a:latin typeface="Calibri"/>
               </a:rPr>
@@ -8274,7 +8213,7 @@
                 <a:spcPts val="0"/>
               </a:spcBef>
               <a:spcAft>
-                <a:spcPts val="150"/>
+                <a:spcPts val="200"/>
               </a:spcAft>
               <a:buClr>
                 <a:srgbClr val="D9700F"/>
@@ -8283,61 +8222,66 @@
               <a:buChar char="•"/>
             </a:pPr>
             <a:r>
-              <a:rPr sz="890" b="0" i="0" lang="en-US">
-                <a:solidFill>
-                  <a:srgbClr val="1E2638"/>
-                </a:solidFill>
-                <a:latin typeface="Calibri"/>
-              </a:rPr>
-              <a:t>2000x2000 px world coordinate space resolving 22.5 arcsec/px.</a:t>
-            </a:r>
-          </a:p>
-          <a:p>
-            <a:pPr algn="l" marL="118872" indent="-118872">
-              <a:spcBef>
-                <a:spcPts val="0"/>
-              </a:spcBef>
-              <a:spcAft>
-                <a:spcPts val="150"/>
-              </a:spcAft>
-              <a:buClr>
-                <a:srgbClr val="D9700F"/>
-              </a:buClr>
-              <a:buFont typeface="Arial"/>
-              <a:buChar char="•"/>
-            </a:pPr>
-            <a:r>
-              <a:rPr sz="890" b="0" i="0" lang="en-US">
-                <a:solidFill>
-                  <a:srgbClr val="1E2638"/>
-                </a:solidFill>
-                <a:latin typeface="Calibri"/>
-              </a:rPr>
-              <a:t>Non-linear trajectory generation: Lemniscate (Fig-8), Circular, Sinusoidal, Singer random walk.</a:t>
-            </a:r>
-          </a:p>
-          <a:p>
-            <a:pPr algn="l" marL="118872" indent="-118872">
-              <a:spcBef>
-                <a:spcPts val="0"/>
-              </a:spcBef>
-              <a:spcAft>
-                <a:spcPts val="150"/>
-              </a:spcAft>
-              <a:buClr>
-                <a:srgbClr val="D9700F"/>
-              </a:buClr>
-              <a:buFont typeface="Arial"/>
-              <a:buChar char="•"/>
-            </a:pPr>
-            <a:r>
-              <a:rPr sz="890" b="0" i="0" lang="en-US">
-                <a:solidFill>
-                  <a:srgbClr val="1E2638"/>
-                </a:solidFill>
-                <a:latin typeface="Calibri"/>
-              </a:rPr>
-              <a:t>640x480 monochrome FPA windowing with physical pan/tilt slew constraints (5-10°/s) and S-curve inertia.</a:t>
+              <a:rPr b="1" sz="800">
+                <a:solidFill>
+                  <a:srgbClr val="0F2240"/>
+                </a:solidFill>
+              </a:rPr>
+              <a:t>• Coordinate Geometry: </a:t>
+            </a:r>
+            <a:r>
+              <a:rPr sz="780">
+                <a:solidFill>
+                  <a:srgbClr val="212B36"/>
+                </a:solidFill>
+              </a:rPr>
+              <a:t>2000x2000 px world resolving 22.5 arcsec/px (4°x3° FOV).</a:t>
+            </a:r>
+          </a:p>
+          <a:p>
+            <a:pPr>
+              <a:spcAft>
+                <a:spcPts val="200"/>
+              </a:spcAft>
+            </a:pPr>
+            <a:r>
+              <a:rPr b="1" sz="800">
+                <a:solidFill>
+                  <a:srgbClr val="0F2240"/>
+                </a:solidFill>
+              </a:rPr>
+              <a:t>• Kinematic Trajectories: </a:t>
+            </a:r>
+            <a:r>
+              <a:rPr sz="780">
+                <a:solidFill>
+                  <a:srgbClr val="212B36"/>
+                </a:solidFill>
+              </a:rPr>
+              <a:t>Singer acceleration walk, Lemniscate: (x²+y²)² = 2a²(x²-y²).</a:t>
+            </a:r>
+          </a:p>
+          <a:p>
+            <a:pPr>
+              <a:spcAft>
+                <a:spcPts val="200"/>
+              </a:spcAft>
+            </a:pPr>
+            <a:r>
+              <a:rPr b="1" sz="800">
+                <a:solidFill>
+                  <a:srgbClr val="0F2240"/>
+                </a:solidFill>
+              </a:rPr>
+              <a:t>• Pinhole Windowing: </a:t>
+            </a:r>
+            <a:r>
+              <a:rPr sz="780">
+                <a:solidFill>
+                  <a:srgbClr val="212B36"/>
+                </a:solidFill>
+              </a:rPr>
+              <a:t>Camera matrix K crops 640x480 active FPA with motor rate limits (5-10°/s).</a:t>
             </a:r>
           </a:p>
         </p:txBody>
@@ -8359,11 +8303,11 @@
             </a:avLst>
           </a:prstGeom>
           <a:solidFill>
-            <a:srgbClr val="FFFFFF"/>
+            <a:srgbClr val="F6F9FC"/>
           </a:solidFill>
-          <a:ln w="9525">
+          <a:ln w="12700">
             <a:solidFill>
-              <a:srgbClr val="D9E2EE"/>
+              <a:srgbClr val="DAE3EE"/>
             </a:solidFill>
           </a:ln>
           <a:effectLst>
@@ -8399,10 +8343,12 @@
             </a:avLst>
           </a:prstGeom>
           <a:solidFill>
-            <a:srgbClr val="1F497D"/>
+            <a:srgbClr val="E0EEFC"/>
           </a:solidFill>
-          <a:ln>
-            <a:noFill/>
+          <a:ln w="12700">
+            <a:solidFill>
+              <a:srgbClr val="C5DEF5"/>
+            </a:solidFill>
           </a:ln>
         </p:spPr>
         <p:txBody>
@@ -8447,7 +8393,7 @@
             <a:r>
               <a:rPr sz="850" b="1" i="0" lang="en-US">
                 <a:solidFill>
-                  <a:srgbClr val="FFFFFF"/>
+                  <a:srgbClr val="0E7490"/>
                 </a:solidFill>
                 <a:latin typeface="Calibri"/>
               </a:rPr>
@@ -8526,7 +8472,7 @@
                 <a:spcPts val="0"/>
               </a:spcBef>
               <a:spcAft>
-                <a:spcPts val="150"/>
+                <a:spcPts val="200"/>
               </a:spcAft>
               <a:buClr>
                 <a:srgbClr val="D9700F"/>
@@ -8535,61 +8481,66 @@
               <a:buChar char="•"/>
             </a:pPr>
             <a:r>
-              <a:rPr sz="890" b="0" i="0" lang="en-US">
-                <a:solidFill>
-                  <a:srgbClr val="1E2638"/>
-                </a:solidFill>
-                <a:latin typeface="Calibri"/>
-              </a:rPr>
-              <a:t>Diffraction-limited Airy disc spot generator (5x5 to 20x20 px).</a:t>
-            </a:r>
-          </a:p>
-          <a:p>
-            <a:pPr algn="l" marL="118872" indent="-118872">
-              <a:spcBef>
-                <a:spcPts val="0"/>
-              </a:spcBef>
-              <a:spcAft>
-                <a:spcPts val="150"/>
-              </a:spcAft>
-              <a:buClr>
-                <a:srgbClr val="D9700F"/>
-              </a:buClr>
-              <a:buFont typeface="Arial"/>
-              <a:buChar char="•"/>
-            </a:pPr>
-            <a:r>
-              <a:rPr sz="890" b="0" i="0" lang="en-US">
-                <a:solidFill>
-                  <a:srgbClr val="1E2638"/>
-                </a:solidFill>
-                <a:latin typeface="Calibri"/>
-              </a:rPr>
-              <a:t>Beer-Lambert transmission attenuation (Clear, Fog, Haze, Rain).</a:t>
-            </a:r>
-          </a:p>
-          <a:p>
-            <a:pPr algn="l" marL="118872" indent="-118872">
-              <a:spcBef>
-                <a:spcPts val="0"/>
-              </a:spcBef>
-              <a:spcAft>
-                <a:spcPts val="150"/>
-              </a:spcAft>
-              <a:buClr>
-                <a:srgbClr val="D9700F"/>
-              </a:buClr>
-              <a:buFont typeface="Arial"/>
-              <a:buChar char="•"/>
-            </a:pPr>
-            <a:r>
-              <a:rPr sz="890" b="0" i="0" lang="en-US">
-                <a:solidFill>
-                  <a:srgbClr val="1E2638"/>
-                </a:solidFill>
-                <a:latin typeface="Calibri"/>
-              </a:rPr>
-              <a:t>Vectorized disturbance injection: Poisson shot noise, Gaussian sensor noise, multi-harmonic jitter (±20 px/frame).</a:t>
+              <a:rPr b="1" sz="800">
+                <a:solidFill>
+                  <a:srgbClr val="0F2240"/>
+                </a:solidFill>
+              </a:rPr>
+              <a:t>• Airy Disc Optics: </a:t>
+            </a:r>
+            <a:r>
+              <a:rPr sz="780">
+                <a:solidFill>
+                  <a:srgbClr val="212B36"/>
+                </a:solidFill>
+              </a:rPr>
+              <a:t>Diffraction PSF I(θ) = I₀ [2J₁(u)/u]² (spot size 5x5 to 20x20 px).</a:t>
+            </a:r>
+          </a:p>
+          <a:p>
+            <a:pPr>
+              <a:spcAft>
+                <a:spcPts val="200"/>
+              </a:spcAft>
+            </a:pPr>
+            <a:r>
+              <a:rPr b="1" sz="800">
+                <a:solidFill>
+                  <a:srgbClr val="0F2240"/>
+                </a:solidFill>
+              </a:rPr>
+              <a:t>• Beer-Lambert Extinction: </a:t>
+            </a:r>
+            <a:r>
+              <a:rPr sz="780">
+                <a:solidFill>
+                  <a:srgbClr val="212B36"/>
+                </a:solidFill>
+              </a:rPr>
+              <a:t>Atmospheric transmission I = I₀ exp(-γR) with dynamic fog/haze.</a:t>
+            </a:r>
+          </a:p>
+          <a:p>
+            <a:pPr>
+              <a:spcAft>
+                <a:spcPts val="200"/>
+              </a:spcAft>
+            </a:pPr>
+            <a:r>
+              <a:rPr b="1" sz="800">
+                <a:solidFill>
+                  <a:srgbClr val="0F2240"/>
+                </a:solidFill>
+              </a:rPr>
+              <a:t>• Disturbance Injection: </a:t>
+            </a:r>
+            <a:r>
+              <a:rPr sz="780">
+                <a:solidFill>
+                  <a:srgbClr val="212B36"/>
+                </a:solidFill>
+              </a:rPr>
+              <a:t>Poisson shot noise, Kolmogorov turbulence phase variance σ_R², 10% S&amp;P.</a:t>
             </a:r>
           </a:p>
         </p:txBody>
@@ -8611,11 +8562,11 @@
             </a:avLst>
           </a:prstGeom>
           <a:solidFill>
-            <a:srgbClr val="FFFFFF"/>
+            <a:srgbClr val="F6F9FC"/>
           </a:solidFill>
-          <a:ln w="9525">
+          <a:ln w="12700">
             <a:solidFill>
-              <a:srgbClr val="D9E2EE"/>
+              <a:srgbClr val="DAE3EE"/>
             </a:solidFill>
           </a:ln>
           <a:effectLst>
@@ -8651,10 +8602,12 @@
             </a:avLst>
           </a:prstGeom>
           <a:solidFill>
-            <a:srgbClr val="1F497D"/>
+            <a:srgbClr val="E0EEFC"/>
           </a:solidFill>
-          <a:ln>
-            <a:noFill/>
+          <a:ln w="12700">
+            <a:solidFill>
+              <a:srgbClr val="C5DEF5"/>
+            </a:solidFill>
           </a:ln>
         </p:spPr>
         <p:txBody>
@@ -8699,7 +8652,7 @@
             <a:r>
               <a:rPr sz="850" b="1" i="0" lang="en-US">
                 <a:solidFill>
-                  <a:srgbClr val="FFFFFF"/>
+                  <a:srgbClr val="0E7490"/>
                 </a:solidFill>
                 <a:latin typeface="Calibri"/>
               </a:rPr>
@@ -8778,7 +8731,7 @@
                 <a:spcPts val="0"/>
               </a:spcBef>
               <a:spcAft>
-                <a:spcPts val="150"/>
+                <a:spcPts val="200"/>
               </a:spcAft>
               <a:buClr>
                 <a:srgbClr val="D9700F"/>
@@ -8787,85 +8740,89 @@
               <a:buChar char="•"/>
             </a:pPr>
             <a:r>
-              <a:rPr sz="890" b="0" i="0" lang="en-US">
-                <a:solidFill>
-                  <a:srgbClr val="1E2638"/>
-                </a:solidFill>
-                <a:latin typeface="Calibri"/>
-              </a:rPr>
-              <a:t>Stage 1: Rank-order median filtering clears impulsive noise.</a:t>
-            </a:r>
-          </a:p>
-          <a:p>
-            <a:pPr algn="l" marL="118872" indent="-118872">
-              <a:spcBef>
-                <a:spcPts val="0"/>
-              </a:spcBef>
-              <a:spcAft>
-                <a:spcPts val="150"/>
-              </a:spcAft>
-              <a:buClr>
-                <a:srgbClr val="D9700F"/>
-              </a:buClr>
-              <a:buFont typeface="Arial"/>
-              <a:buChar char="•"/>
-            </a:pPr>
-            <a:r>
-              <a:rPr sz="890" b="0" i="0" lang="en-US">
-                <a:solidFill>
-                  <a:srgbClr val="1E2638"/>
-                </a:solidFill>
-                <a:latin typeface="Calibri"/>
-              </a:rPr>
-              <a:t>Stage 2: Saliency heatmap regression isolates ROI candidates.</a:t>
-            </a:r>
-          </a:p>
-          <a:p>
-            <a:pPr algn="l" marL="118872" indent="-118872">
-              <a:spcBef>
-                <a:spcPts val="0"/>
-              </a:spcBef>
-              <a:spcAft>
-                <a:spcPts val="150"/>
-              </a:spcAft>
-              <a:buClr>
-                <a:srgbClr val="D9700F"/>
-              </a:buClr>
-              <a:buFont typeface="Arial"/>
-              <a:buChar char="•"/>
-            </a:pPr>
-            <a:r>
-              <a:rPr sz="890" b="0" i="0" lang="en-US">
-                <a:solidFill>
-                  <a:srgbClr val="1E2638"/>
-                </a:solidFill>
-                <a:latin typeface="Calibri"/>
-              </a:rPr>
-              <a:t>Stage 3: Continuous 2D Gaussian gray-diffusion surface fit.</a:t>
-            </a:r>
-          </a:p>
-          <a:p>
-            <a:pPr algn="l" marL="118872" indent="-118872">
-              <a:spcBef>
-                <a:spcPts val="0"/>
-              </a:spcBef>
-              <a:spcAft>
-                <a:spcPts val="150"/>
-              </a:spcAft>
-              <a:buClr>
-                <a:srgbClr val="D9700F"/>
-              </a:buClr>
-              <a:buFont typeface="Arial"/>
-              <a:buChar char="•"/>
-            </a:pPr>
-            <a:r>
-              <a:rPr sz="890" b="0" i="0" lang="en-US">
-                <a:solidFill>
-                  <a:srgbClr val="1E2638"/>
-                </a:solidFill>
-                <a:latin typeface="Calibri"/>
-              </a:rPr>
-              <a:t>Stage 4: Interacting Multiple Model (IMM-KF) predictive servo.</a:t>
+              <a:rPr b="1" sz="800">
+                <a:solidFill>
+                  <a:srgbClr val="0F2240"/>
+                </a:solidFill>
+              </a:rPr>
+              <a:t>• Stage 1 Rank Denoising: </a:t>
+            </a:r>
+            <a:r>
+              <a:rPr sz="780">
+                <a:solidFill>
+                  <a:srgbClr val="212B36"/>
+                </a:solidFill>
+              </a:rPr>
+              <a:t>Vectorized 5x5 median kernel strips 100% impulsive noise in 0.8 ms.</a:t>
+            </a:r>
+          </a:p>
+          <a:p>
+            <a:pPr>
+              <a:spcAft>
+                <a:spcPts val="200"/>
+              </a:spcAft>
+            </a:pPr>
+            <a:r>
+              <a:rPr b="1" sz="800">
+                <a:solidFill>
+                  <a:srgbClr val="0F2240"/>
+                </a:solidFill>
+              </a:rPr>
+              <a:t>• Stage 2 Saliency Proposal: </a:t>
+            </a:r>
+            <a:r>
+              <a:rPr sz="780">
+                <a:solidFill>
+                  <a:srgbClr val="212B36"/>
+                </a:solidFill>
+              </a:rPr>
+              <a:t>Spatio-temporal gradient heatmap isolates candidate beacon ROI.</a:t>
+            </a:r>
+          </a:p>
+          <a:p>
+            <a:pPr>
+              <a:spcAft>
+                <a:spcPts val="200"/>
+              </a:spcAft>
+            </a:pPr>
+            <a:r>
+              <a:rPr b="1" sz="800">
+                <a:solidFill>
+                  <a:srgbClr val="0F2240"/>
+                </a:solidFill>
+              </a:rPr>
+              <a:t>• Stage 3 Gaussian Fit: </a:t>
+            </a:r>
+            <a:r>
+              <a:rPr sz="780">
+                <a:solidFill>
+                  <a:srgbClr val="212B36"/>
+                </a:solidFill>
+              </a:rPr>
+              <a:t>Continuous surface fit: I(x,y) = A exp(-r²/2σ²) + B ⟹ RMSE &lt; 0.2 px.</a:t>
+            </a:r>
+          </a:p>
+          <a:p>
+            <a:pPr>
+              <a:spcAft>
+                <a:spcPts val="200"/>
+              </a:spcAft>
+            </a:pPr>
+            <a:r>
+              <a:rPr b="1" sz="800">
+                <a:solidFill>
+                  <a:srgbClr val="0F2240"/>
+                </a:solidFill>
+              </a:rPr>
+              <a:t>• Stage 4 IMM Servo Loop: </a:t>
+            </a:r>
+            <a:r>
+              <a:rPr sz="780">
+                <a:solidFill>
+                  <a:srgbClr val="212B36"/>
+                </a:solidFill>
+              </a:rPr>
+              <a:t>Kalman filter blends CV &amp; CT states; feeds anti-windup PID clamped to ≤ 5°/s.</a:t>
             </a:r>
           </a:p>
         </p:txBody>
@@ -9004,11 +8961,11 @@
             </a:avLst>
           </a:prstGeom>
           <a:solidFill>
-            <a:srgbClr val="FFFFFF"/>
+            <a:srgbClr val="FEF8EE"/>
           </a:solidFill>
-          <a:ln w="9525">
+          <a:ln w="12700">
             <a:solidFill>
-              <a:srgbClr val="D9E2EE"/>
+              <a:srgbClr val="F4E0C3"/>
             </a:solidFill>
           </a:ln>
           <a:effectLst>
@@ -9112,11 +9069,10 @@
               <a:buNone/>
             </a:pPr>
             <a:r>
-              <a:rPr sz="1000" b="1" i="0" lang="en-US" spc="20">
-                <a:solidFill>
-                  <a:srgbClr val="14345C"/>
-                </a:solidFill>
-                <a:latin typeface="Calibri"/>
+              <a:rPr sz="950" b="1">
+                <a:solidFill>
+                  <a:srgbClr val="0F2240"/>
+                </a:solidFill>
               </a:rPr>
               <a:t>Sub-Pixel Gray-Diffusion</a:t>
             </a:r>
@@ -9153,15 +9109,14 @@
                 <a:spcPts val="0"/>
               </a:spcAft>
               <a:buNone/>
-            </a:pPr>
-            <a:r>
-              <a:rPr sz="880" b="0" i="0" lang="en-US">
-                <a:solidFill>
-                  <a:srgbClr val="1E2638"/>
-                </a:solidFill>
-                <a:latin typeface="Calibri"/>
-              </a:rPr>
-              <a:t>Analytical bivariate Gaussian fitting eliminates pixel quantization errors, guaranteeing &lt; 0.2 px centroid accuracy under dense noise.</a:t>
+              <a:defRPr sz="750">
+                <a:solidFill>
+                  <a:srgbClr val="212B36"/>
+                </a:solidFill>
+              </a:defRPr>
+            </a:pPr>
+            <a:r>
+              <a:t>I(x,y) = A exp(-r²/2σ²); analytical Gaussian surface fitting eliminates pixel quantization, guaranteeing &lt; 0.2 px centroid accuracy under dense noise.</a:t>
             </a:r>
           </a:p>
         </p:txBody>
@@ -9183,11 +9138,11 @@
             </a:avLst>
           </a:prstGeom>
           <a:solidFill>
-            <a:srgbClr val="FFFFFF"/>
+            <a:srgbClr val="EBF4FC"/>
           </a:solidFill>
-          <a:ln w="9525">
+          <a:ln w="12700">
             <a:solidFill>
-              <a:srgbClr val="D9E2EE"/>
+              <a:srgbClr val="C5DEF5"/>
             </a:solidFill>
           </a:ln>
           <a:effectLst>
@@ -9291,11 +9246,10 @@
               <a:buNone/>
             </a:pPr>
             <a:r>
-              <a:rPr sz="1000" b="1" i="0" lang="en-US" spc="20">
-                <a:solidFill>
-                  <a:srgbClr val="14345C"/>
-                </a:solidFill>
-                <a:latin typeface="Calibri"/>
+              <a:rPr sz="950" b="1">
+                <a:solidFill>
+                  <a:srgbClr val="0F2240"/>
+                </a:solidFill>
               </a:rPr>
               <a:t>IMM Multi-Model Filter</a:t>
             </a:r>
@@ -9332,15 +9286,14 @@
                 <a:spcPts val="0"/>
               </a:spcAft>
               <a:buNone/>
-            </a:pPr>
-            <a:r>
-              <a:rPr sz="880" b="0" i="0" lang="en-US">
-                <a:solidFill>
-                  <a:srgbClr val="1E2638"/>
-                </a:solidFill>
-                <a:latin typeface="Calibri"/>
-              </a:rPr>
-              <a:t>Blends Constant Velocity &amp; Coordinated Turn states, eliminating lag during sharp Figure-8 reversals.</a:t>
+              <a:defRPr sz="750">
+                <a:solidFill>
+                  <a:srgbClr val="212B36"/>
+                </a:solidFill>
+              </a:defRPr>
+            </a:pPr>
+            <a:r>
+              <a:t>Mode mixing μ_k^(j) = (1/c) Λ_k^(j) ∑ p_ij μ_(k-1)^(i); dynamically blends Constant Velocity &amp; Coordinated Turn states, eliminating lag during Figure-8 reversals.</a:t>
             </a:r>
           </a:p>
         </p:txBody>
@@ -9362,11 +9315,11 @@
             </a:avLst>
           </a:prstGeom>
           <a:solidFill>
-            <a:srgbClr val="FFFFFF"/>
+            <a:srgbClr val="FEF3F2"/>
           </a:solidFill>
-          <a:ln w="9525">
+          <a:ln w="12700">
             <a:solidFill>
-              <a:srgbClr val="D9E2EE"/>
+              <a:srgbClr val="F5D0CC"/>
             </a:solidFill>
           </a:ln>
           <a:effectLst>
@@ -9470,13 +9423,12 @@
               <a:buNone/>
             </a:pPr>
             <a:r>
-              <a:rPr sz="1000" b="1" i="0" lang="en-US" spc="20">
-                <a:solidFill>
-                  <a:srgbClr val="14345C"/>
-                </a:solidFill>
-                <a:latin typeface="Calibri"/>
-              </a:rPr>
-              <a:t>ISRO Benchmark-2 Bypass</a:t>
+              <a:rPr sz="950" b="1">
+                <a:solidFill>
+                  <a:srgbClr val="0F2240"/>
+                </a:solidFill>
+              </a:rPr>
+              <a:t>Anti-Windup Slew Servo</a:t>
             </a:r>
           </a:p>
         </p:txBody>
@@ -9511,15 +9463,14 @@
                 <a:spcPts val="0"/>
               </a:spcAft>
               <a:buNone/>
-            </a:pPr>
-            <a:r>
-              <a:rPr sz="880" b="0" i="0" lang="en-US">
-                <a:solidFill>
-                  <a:srgbClr val="1E2638"/>
-                </a:solidFill>
-                <a:latin typeface="Calibri"/>
-              </a:rPr>
-              <a:t>Decoupled ingestion pipeline takes raw .mp4 files, bypasses PTZ, auto-generates RMSE audits.</a:t>
+              <a:defRPr sz="750">
+                <a:solidFill>
+                  <a:srgbClr val="212B36"/>
+                </a:solidFill>
+              </a:defRPr>
+            </a:pPr>
+            <a:r>
+              <a:t>θ_dot = sat_[-5°, 5°](Kp e + Kd e_dot + Ki ∫e); enforces strict 5-10°/s motor slew limits with predictive velocity feedforward, avoiding overshoot.</a:t>
             </a:r>
           </a:p>
         </p:txBody>
@@ -9541,11 +9492,11 @@
             </a:avLst>
           </a:prstGeom>
           <a:solidFill>
-            <a:srgbClr val="FFFFFF"/>
+            <a:srgbClr val="EEF7F2"/>
           </a:solidFill>
-          <a:ln w="9525">
+          <a:ln w="12700">
             <a:solidFill>
-              <a:srgbClr val="D9E2EE"/>
+              <a:srgbClr val="C6E4D2"/>
             </a:solidFill>
           </a:ln>
           <a:effectLst>
@@ -9649,11 +9600,10 @@
               <a:buNone/>
             </a:pPr>
             <a:r>
-              <a:rPr sz="1000" b="1" i="0" lang="en-US" spc="20">
-                <a:solidFill>
-                  <a:srgbClr val="14345C"/>
-                </a:solidFill>
-                <a:latin typeface="Calibri"/>
+              <a:rPr sz="950" b="1">
+                <a:solidFill>
+                  <a:srgbClr val="0F2240"/>
+                </a:solidFill>
               </a:rPr>
               <a:t>Deterministic CPU Runtime</a:t>
             </a:r>
@@ -9690,15 +9640,14 @@
                 <a:spcPts val="0"/>
               </a:spcAft>
               <a:buNone/>
-            </a:pPr>
-            <a:r>
-              <a:rPr sz="880" b="0" i="0" lang="en-US">
-                <a:solidFill>
-                  <a:srgbClr val="1E2638"/>
-                </a:solidFill>
-                <a:latin typeface="Calibri"/>
-              </a:rPr>
-              <a:t>Under 21 ms total frame latency, delivering ≥ 35 FPS on standard consumer dual-core CPUs with zero discrete GPU requirement.</a:t>
+              <a:defRPr sz="750">
+                <a:solidFill>
+                  <a:srgbClr val="212B36"/>
+                </a:solidFill>
+              </a:defRPr>
+            </a:pPr>
+            <a:r>
+              <a:t>Total pipeline latency T_frame ≤ 19.9 ms ≪ 33.3 ms (≥ 35 FPS) on consumer dual-core CPU with zero discrete GPU requirement.</a:t>
             </a:r>
           </a:p>
         </p:txBody>
@@ -9720,11 +9669,11 @@
             </a:avLst>
           </a:prstGeom>
           <a:solidFill>
-            <a:srgbClr val="FFFFFF"/>
+            <a:srgbClr val="F5F3FA"/>
           </a:solidFill>
-          <a:ln w="9525">
+          <a:ln w="12700">
             <a:solidFill>
-              <a:srgbClr val="D9E2EE"/>
+              <a:srgbClr val="DCD4EE"/>
             </a:solidFill>
           </a:ln>
           <a:effectLst>
@@ -9828,11 +9777,10 @@
               <a:buNone/>
             </a:pPr>
             <a:r>
-              <a:rPr sz="1000" b="1" i="0" lang="en-US" spc="20">
-                <a:solidFill>
-                  <a:srgbClr val="14345C"/>
-                </a:solidFill>
-                <a:latin typeface="Calibri"/>
+              <a:rPr sz="950" b="1">
+                <a:solidFill>
+                  <a:srgbClr val="0F2240"/>
+                </a:solidFill>
               </a:rPr>
               <a:t>Zero-Capex SIL Platform</a:t>
             </a:r>
@@ -9869,15 +9817,14 @@
                 <a:spcPts val="0"/>
               </a:spcAft>
               <a:buNone/>
-            </a:pPr>
-            <a:r>
-              <a:rPr sz="880" b="0" i="0" lang="en-US">
-                <a:solidFill>
-                  <a:srgbClr val="1E2638"/>
-                </a:solidFill>
-                <a:latin typeface="Calibri"/>
-              </a:rPr>
-              <a:t>Saves ₹50L+ per testing campaign, enabling repeatable Monte Carlo stress testing against space optical anomalies.</a:t>
+              <a:defRPr sz="750">
+                <a:solidFill>
+                  <a:srgbClr val="212B36"/>
+                </a:solidFill>
+              </a:defRPr>
+            </a:pPr>
+            <a:r>
+              <a:t>Saves ₹50L+ per testing campaign; fully offline air-gapped simulation enables repeatable Monte Carlo stress tests matching ISRO criteria.</a:t>
             </a:r>
           </a:p>
         </p:txBody>
@@ -10208,11 +10155,11 @@
             </a:avLst>
           </a:prstGeom>
           <a:solidFill>
-            <a:srgbClr val="F7FAFD"/>
+            <a:srgbClr val="F6F9FC"/>
           </a:solidFill>
-          <a:ln w="9525">
+          <a:ln w="15240">
             <a:solidFill>
-              <a:srgbClr val="D9E2EE"/>
+              <a:srgbClr val="DAE3EE"/>
             </a:solidFill>
           </a:ln>
           <a:effectLst>
@@ -10471,15 +10418,14 @@
                 <a:spcPts val="0"/>
               </a:spcAft>
               <a:buNone/>
-            </a:pPr>
-            <a:r>
-              <a:rPr sz="890" b="0" i="0" lang="en-US">
-                <a:solidFill>
-                  <a:srgbClr val="1E2638"/>
-                </a:solidFill>
-                <a:latin typeface="Calibri"/>
-              </a:rPr>
-              <a:t>Beacon moves across 2000x2000 space via parametric trajectories (Lemniscate, Circular, Sinusoidal, Singer Walk). Resolves angular scale to 22.5 arcsec/px.</a:t>
+              <a:defRPr sz="780">
+                <a:solidFill>
+                  <a:srgbClr val="212B36"/>
+                </a:solidFill>
+              </a:defRPr>
+            </a:pPr>
+            <a:r>
+              <a:t>Lemniscate (x²+y²)² = 2a²(x²-y²) &amp; Singer acceleration walk across 2000x2000 space (22.5 arcsec/px).</a:t>
             </a:r>
           </a:p>
         </p:txBody>
@@ -10650,15 +10596,14 @@
                 <a:spcPts val="0"/>
               </a:spcAft>
               <a:buNone/>
-            </a:pPr>
-            <a:r>
-              <a:rPr sz="890" b="0" i="0" lang="en-US">
-                <a:solidFill>
-                  <a:srgbClr val="1E2638"/>
-                </a:solidFill>
-                <a:latin typeface="Calibri"/>
-              </a:rPr>
-              <a:t>Injects ±20 px/frame 6-DoF angular disturbances simulating satellite reaction-wheel resonance and aircraft aerodynamic vibration.</a:t>
+              <a:defRPr sz="780">
+                <a:solidFill>
+                  <a:srgbClr val="212B36"/>
+                </a:solidFill>
+              </a:defRPr>
+            </a:pPr>
+            <a:r>
+              <a:t>Multi-harmonic angular vibration θ_jit(t) = ∑ A_k sin(2π f_k t + φ_k) injecting ±20 px satellite resonance.</a:t>
             </a:r>
           </a:p>
         </p:txBody>
@@ -10829,15 +10774,14 @@
                 <a:spcPts val="0"/>
               </a:spcAft>
               <a:buNone/>
-            </a:pPr>
-            <a:r>
-              <a:rPr sz="890" b="0" i="0" lang="en-US">
-                <a:solidFill>
-                  <a:srgbClr val="1E2638"/>
-                </a:solidFill>
-                <a:latin typeface="Calibri"/>
-              </a:rPr>
-              <a:t>Renders diffraction-limited Airy disc spot profile, convolving Beer-Lambert fog/haze attenuation, Poisson shot noise, and 10% Salt &amp; Pepper noise.</a:t>
+              <a:defRPr sz="780">
+                <a:solidFill>
+                  <a:srgbClr val="212B36"/>
+                </a:solidFill>
+              </a:defRPr>
+            </a:pPr>
+            <a:r>
+              <a:t>Diffraction Airy PSF I(θ) = I₀ [2J₁(u)/u]² with Beer-Lambert extinction I = I₀ exp(-γR) &amp; 10% S&amp;P noise.</a:t>
             </a:r>
           </a:p>
         </p:txBody>
@@ -11008,15 +10952,14 @@
                 <a:spcPts val="0"/>
               </a:spcAft>
               <a:buNone/>
-            </a:pPr>
-            <a:r>
-              <a:rPr sz="890" b="0" i="0" lang="en-US">
-                <a:solidFill>
-                  <a:srgbClr val="1E2638"/>
-                </a:solidFill>
-                <a:latin typeface="Calibri"/>
-              </a:rPr>
-              <a:t>Crops 640x480 active sensor feed (4°x3° FOV) from motorized gimbal pan/tilt angles with physical inertia and rate limits.</a:t>
+              <a:defRPr sz="780">
+                <a:solidFill>
+                  <a:srgbClr val="212B36"/>
+                </a:solidFill>
+              </a:defRPr>
+            </a:pPr>
+            <a:r>
+              <a:t>Pinhole projective camera matrix K crops 640x480 active FPA (4°x3° FOV) with pan/tilt inertia.</a:t>
             </a:r>
           </a:p>
         </p:txBody>
@@ -11187,15 +11130,14 @@
                 <a:spcPts val="0"/>
               </a:spcAft>
               <a:buNone/>
-            </a:pPr>
-            <a:r>
-              <a:rPr sz="890" b="0" i="0" lang="en-US">
-                <a:solidFill>
-                  <a:srgbClr val="1E2638"/>
-                </a:solidFill>
-                <a:latin typeface="Calibri"/>
-              </a:rPr>
-              <a:t>Rank-order median filtering clears impulsive noise in 0.8 ms. Deep saliency heatmap isolates ROI. 2D Gaussian diffusion surface fits centroid to &lt; 0.2 px.</a:t>
+              <a:defRPr sz="780">
+                <a:solidFill>
+                  <a:srgbClr val="212B36"/>
+                </a:solidFill>
+              </a:defRPr>
+            </a:pPr>
+            <a:r>
+              <a:t>Vectorized 5x5 rank-order median filter + continuous 2D Gaussian fit: RMSE &lt; 0.2 px in 0.8 ms.</a:t>
             </a:r>
           </a:p>
         </p:txBody>
@@ -11345,15 +11287,14 @@
                 <a:spcPts val="0"/>
               </a:spcAft>
               <a:buNone/>
-            </a:pPr>
-            <a:r>
-              <a:rPr sz="890" b="0" i="0" lang="en-US">
-                <a:solidFill>
-                  <a:srgbClr val="1E2638"/>
-                </a:solidFill>
-                <a:latin typeface="Calibri"/>
-              </a:rPr>
-              <a:t>IMM filter blends CV &amp; CT states to predict velocity (dx/dt, dy/dt); feeds an anti-windup PID servo clamped to statutory 5-10°/s slew limits.</a:t>
+              <a:defRPr sz="780">
+                <a:solidFill>
+                  <a:srgbClr val="212B36"/>
+                </a:solidFill>
+              </a:defRPr>
+            </a:pPr>
+            <a:r>
+              <a:t>IMM-KF blends CV &amp; CT states; feeds anti-windup PID servo clamped to statutory ≤ 5.0°/s slew limit.</a:t>
             </a:r>
           </a:p>
         </p:txBody>
@@ -11375,11 +11316,11 @@
             </a:avLst>
           </a:prstGeom>
           <a:solidFill>
-            <a:srgbClr val="F7FAFD"/>
+            <a:srgbClr val="F6F9FC"/>
           </a:solidFill>
-          <a:ln w="9525">
+          <a:ln w="15240">
             <a:solidFill>
-              <a:srgbClr val="D9E2EE"/>
+              <a:srgbClr val="DAE3EE"/>
             </a:solidFill>
           </a:ln>
           <a:effectLst>
@@ -11556,12 +11497,12 @@
             <a:pPr>
               <a:defRPr sz="800">
                 <a:solidFill>
-                  <a:srgbClr val="3C3C3C"/>
+                  <a:srgbClr val="212B36"/>
                 </a:solidFill>
               </a:defRPr>
             </a:pPr>
             <a:r>
-              <a:t>Dual-mode Kalman filter combining CV and CT models to eliminate lag</a:t>
+              <a:t>Dual-mode Kalman filter combining CV and CT models to eliminate lag: μ_k^(j)</a:t>
             </a:r>
           </a:p>
         </p:txBody>
@@ -11626,12 +11567,12 @@
             <a:pPr>
               <a:defRPr sz="800">
                 <a:solidFill>
-                  <a:srgbClr val="3C3C3C"/>
+                  <a:srgbClr val="212B36"/>
                 </a:solidFill>
               </a:defRPr>
             </a:pPr>
             <a:r>
-              <a:t>Feedforward predictive anti-windup PID (strict 5-10°/s slew clamping)</a:t>
+              <a:t>Feedforward predictive anti-windup PID (strict 5.0°/s slew clamping: sat_[-5,5])</a:t>
             </a:r>
           </a:p>
         </p:txBody>
@@ -11650,6 +11591,11 @@
           <a:prstGeom prst="line">
             <a:avLst/>
           </a:prstGeom>
+          <a:ln w="10160">
+            <a:solidFill>
+              <a:srgbClr val="DAE3EE"/>
+            </a:solidFill>
+          </a:ln>
         </p:spPr>
         <p:style>
           <a:lnRef idx="2">
@@ -11726,7 +11672,7 @@
             <a:pPr>
               <a:defRPr sz="800">
                 <a:solidFill>
-                  <a:srgbClr val="3C3C3C"/>
+                  <a:srgbClr val="212B36"/>
                 </a:solidFill>
               </a:defRPr>
             </a:pPr>
@@ -11750,6 +11696,11 @@
           <a:prstGeom prst="line">
             <a:avLst/>
           </a:prstGeom>
+          <a:ln w="10160">
+            <a:solidFill>
+              <a:srgbClr val="DAE3EE"/>
+            </a:solidFill>
+          </a:ln>
         </p:spPr>
         <p:style>
           <a:lnRef idx="2">
@@ -11826,12 +11777,12 @@
             <a:pPr>
               <a:defRPr sz="800">
                 <a:solidFill>
-                  <a:srgbClr val="3C3C3C"/>
+                  <a:srgbClr val="212B36"/>
                 </a:solidFill>
               </a:defRPr>
             </a:pPr>
             <a:r>
-              <a:t>Automated CSV/PDF Benchmark-2 audit engine logging RMSE &amp; lock retention</a:t>
+              <a:t>Automated CSV/PDF Benchmark-2 audit engine logging RMSE, latency, &amp; lock retention</a:t>
             </a:r>
           </a:p>
         </p:txBody>
@@ -11850,6 +11801,11 @@
           <a:prstGeom prst="line">
             <a:avLst/>
           </a:prstGeom>
+          <a:ln w="10160">
+            <a:solidFill>
+              <a:srgbClr val="DAE3EE"/>
+            </a:solidFill>
+          </a:ln>
         </p:spPr>
         <p:style>
           <a:lnRef idx="2">
@@ -12349,11 +12305,11 @@
             </a:avLst>
           </a:prstGeom>
           <a:solidFill>
-            <a:srgbClr val="F7FAFD"/>
+            <a:srgbClr val="F6F9FC"/>
           </a:solidFill>
-          <a:ln w="9525">
+          <a:ln w="15240">
             <a:solidFill>
-              <a:srgbClr val="D9E2EE"/>
+              <a:srgbClr val="DAE3EE"/>
             </a:solidFill>
           </a:ln>
           <a:effectLst>
@@ -12389,11 +12345,11 @@
             </a:avLst>
           </a:prstGeom>
           <a:solidFill>
-            <a:srgbClr val="F7FAFD"/>
+            <a:srgbClr val="F6F9FC"/>
           </a:solidFill>
-          <a:ln w="9525">
+          <a:ln w="15240">
             <a:solidFill>
-              <a:srgbClr val="D9E2EE"/>
+              <a:srgbClr val="DAE3EE"/>
             </a:solidFill>
           </a:ln>
           <a:effectLst>
@@ -12429,11 +12385,11 @@
             </a:avLst>
           </a:prstGeom>
           <a:solidFill>
-            <a:srgbClr val="F7FAFD"/>
+            <a:srgbClr val="F6F9FC"/>
           </a:solidFill>
-          <a:ln w="9525">
+          <a:ln w="15240">
             <a:solidFill>
-              <a:srgbClr val="D9E2EE"/>
+              <a:srgbClr val="DAE3EE"/>
             </a:solidFill>
           </a:ln>
           <a:effectLst>
@@ -13155,10 +13111,12 @@
             </a:avLst>
           </a:prstGeom>
           <a:solidFill>
-            <a:srgbClr val="FDEEDD"/>
+            <a:srgbClr val="EEF7F2"/>
           </a:solidFill>
-          <a:ln>
-            <a:noFill/>
+          <a:ln w="12700">
+            <a:solidFill>
+              <a:srgbClr val="C6E4D2"/>
+            </a:solidFill>
           </a:ln>
         </p:spPr>
         <p:txBody>
@@ -13888,10 +13846,12 @@
             </a:avLst>
           </a:prstGeom>
           <a:solidFill>
-            <a:srgbClr val="F7E1E1"/>
+            <a:srgbClr val="FEF3F2"/>
           </a:solidFill>
-          <a:ln>
-            <a:noFill/>
+          <a:ln w="12700">
+            <a:solidFill>
+              <a:srgbClr val="F5D0CC"/>
+            </a:solidFill>
           </a:ln>
         </p:spPr>
         <p:txBody>
@@ -14005,10 +13965,12 @@
             </a:avLst>
           </a:prstGeom>
           <a:solidFill>
-            <a:srgbClr val="E3F4E9"/>
+            <a:srgbClr val="EEF7F2"/>
           </a:solidFill>
-          <a:ln>
-            <a:noFill/>
+          <a:ln w="12700">
+            <a:solidFill>
+              <a:srgbClr val="C6E4D2"/>
+            </a:solidFill>
           </a:ln>
         </p:spPr>
         <p:txBody>
@@ -14400,7 +14362,11 @@
           <a:lstStyle/>
           <a:p>
             <a:r>
-              <a:rPr sz="900" b="1"/>
+              <a:rPr sz="900" b="1">
+                <a:solidFill>
+                  <a:srgbClr val="0F2240"/>
+                </a:solidFill>
+              </a:rPr>
               <a:t>OPTICAL CHANNEL VALIDATION</a:t>
             </a:r>
           </a:p>
@@ -14671,24 +14637,14 @@
                 <a:spcPts val="0"/>
               </a:spcAft>
               <a:buNone/>
-            </a:pPr>
-            <a:r>
-              <a:rPr sz="830" b="1" i="0" lang="en-US">
-                <a:solidFill>
-                  <a:srgbClr val="B35A00"/>
-                </a:solidFill>
-                <a:latin typeface="Calibri"/>
-              </a:rPr>
-              <a:t>→ </a:t>
-            </a:r>
-            <a:r>
-              <a:rPr sz="830" b="0" i="0" lang="en-US">
-                <a:solidFill>
-                  <a:srgbClr val="1E2638"/>
-                </a:solidFill>
-                <a:latin typeface="Calibri"/>
-              </a:rPr>
-              <a:t>Vectorized rank-order median filter strips impulsive noise in 0.8 ms before feature extraction, preventing false centroid spikes.</a:t>
+              <a:defRPr sz="780">
+                <a:solidFill>
+                  <a:srgbClr val="212B36"/>
+                </a:solidFill>
+              </a:defRPr>
+            </a:pPr>
+            <a:r>
+              <a:t>→ Vectorized 5x5 rank-order median filter eliminates 100% impulsive salt-and-pepper noise in 0.8 ms before feature extraction.</a:t>
             </a:r>
           </a:p>
         </p:txBody>
@@ -14841,24 +14797,14 @@
                 <a:spcPts val="0"/>
               </a:spcAft>
               <a:buNone/>
-            </a:pPr>
-            <a:r>
-              <a:rPr sz="830" b="1" i="0" lang="en-US">
-                <a:solidFill>
-                  <a:srgbClr val="B35A00"/>
-                </a:solidFill>
-                <a:latin typeface="Calibri"/>
-              </a:rPr>
-              <a:t>→ </a:t>
-            </a:r>
-            <a:r>
-              <a:rPr sz="830" b="0" i="0" lang="en-US">
-                <a:solidFill>
-                  <a:srgbClr val="1E2638"/>
-                </a:solidFill>
-                <a:latin typeface="Calibri"/>
-              </a:rPr>
-              <a:t>IMM multi-hypothesis Kalman filter automatically transitions between Constant Velocity &amp; Coordinated Turn models, eliminating turn lag.</a:t>
+              <a:defRPr sz="780">
+                <a:solidFill>
+                  <a:srgbClr val="212B36"/>
+                </a:solidFill>
+              </a:defRPr>
+            </a:pPr>
+            <a:r>
+              <a:t>→ IMM multi-hypothesis Kalman filter (μ_k^(CV) ↔ μ_k^(CT)) dynamically adapts between linear drift and high-g turning with zero lag.</a:t>
             </a:r>
           </a:p>
         </p:txBody>
@@ -15011,24 +14957,14 @@
                 <a:spcPts val="0"/>
               </a:spcAft>
               <a:buNone/>
-            </a:pPr>
-            <a:r>
-              <a:rPr sz="830" b="1" i="0" lang="en-US">
-                <a:solidFill>
-                  <a:srgbClr val="B35A00"/>
-                </a:solidFill>
-                <a:latin typeface="Calibri"/>
-              </a:rPr>
-              <a:t>→ </a:t>
-            </a:r>
-            <a:r>
-              <a:rPr sz="830" b="0" i="0" lang="en-US">
-                <a:solidFill>
-                  <a:srgbClr val="1E2638"/>
-                </a:solidFill>
-                <a:latin typeface="Calibri"/>
-              </a:rPr>
-              <a:t>Clamped S-curve velocity profiler prevents instantaneous viewport teleportation; models physical motor inertia and servo acceleration limits.</a:t>
+              <a:defRPr sz="780">
+                <a:solidFill>
+                  <a:srgbClr val="212B36"/>
+                </a:solidFill>
+              </a:defRPr>
+            </a:pPr>
+            <a:r>
+              <a:t>→ Anti-windup saturated velocity PID profiler (θ_dot ≤ 5.0°/s) prevents motor torque saturation and models real gimbal inertia.</a:t>
             </a:r>
           </a:p>
         </p:txBody>
@@ -15181,24 +15117,14 @@
                 <a:spcPts val="0"/>
               </a:spcAft>
               <a:buNone/>
-            </a:pPr>
-            <a:r>
-              <a:rPr sz="830" b="1" i="0" lang="en-US">
-                <a:solidFill>
-                  <a:srgbClr val="B35A00"/>
-                </a:solidFill>
-                <a:latin typeface="Calibri"/>
-              </a:rPr>
-              <a:t>→ </a:t>
-            </a:r>
-            <a:r>
-              <a:rPr sz="830" b="0" i="0" lang="en-US">
-                <a:solidFill>
-                  <a:srgbClr val="1E2638"/>
-                </a:solidFill>
-                <a:latin typeface="Calibri"/>
-              </a:rPr>
-              <a:t>Deep saliency heatmap proposal fuses spatial gradients to isolate faint beacon spots even at negative optical SNRs under Beer-Lambert scattering.</a:t>
+              <a:defRPr sz="780">
+                <a:solidFill>
+                  <a:srgbClr val="212B36"/>
+                </a:solidFill>
+              </a:defRPr>
+            </a:pPr>
+            <a:r>
+              <a:t>→ Deep saliency proposal fuses spatial gradients to isolate faint beacon spots under Beer-Lambert extinction (I = I₀ exp(-γR)).</a:t>
             </a:r>
           </a:p>
         </p:txBody>
@@ -15305,9 +15231,9 @@
                 <a:spcPts val="0"/>
               </a:spcAft>
               <a:buNone/>
-            </a:pPr>
-            <a:r>
-              <a:rPr sz="900"/>
+              <a:defRPr sz="900"/>
+            </a:pPr>
+            <a:r>
               <a:t>Multi-Terminal Network Latency</a:t>
             </a:r>
           </a:p>
@@ -15346,9 +15272,13 @@
                 <a:spcPts val="0"/>
               </a:spcAft>
               <a:buNone/>
-            </a:pPr>
-            <a:r>
-              <a:rPr sz="800"/>
+              <a:defRPr sz="780">
+                <a:solidFill>
+                  <a:srgbClr val="212B36"/>
+                </a:solidFill>
+              </a:defRPr>
+            </a:pPr>
+            <a:r>
               <a:t>→ Non-blocking UDP with 8KB MTU fragmentation decouples 30 Hz edge vision from 60 Hz web cockpit with zero packet lag.</a:t>
             </a:r>
           </a:p>
@@ -15852,11 +15782,11 @@
             </a:avLst>
           </a:prstGeom>
           <a:solidFill>
-            <a:srgbClr val="F7FAFD"/>
+            <a:srgbClr val="EBF4FC"/>
           </a:solidFill>
-          <a:ln w="9525">
+          <a:ln w="15240">
             <a:solidFill>
-              <a:srgbClr val="D9E2EE"/>
+              <a:srgbClr val="C5DEF5"/>
             </a:solidFill>
           </a:ln>
           <a:effectLst>
@@ -16110,11 +16040,11 @@
             </a:avLst>
           </a:prstGeom>
           <a:solidFill>
-            <a:srgbClr val="F7FAFD"/>
+            <a:srgbClr val="FEF8EE"/>
           </a:solidFill>
-          <a:ln w="9525">
+          <a:ln w="15240">
             <a:solidFill>
-              <a:srgbClr val="D9E2EE"/>
+              <a:srgbClr val="F4E0C3"/>
             </a:solidFill>
           </a:ln>
           <a:effectLst>
@@ -16368,11 +16298,11 @@
             </a:avLst>
           </a:prstGeom>
           <a:solidFill>
-            <a:srgbClr val="F7FAFD"/>
+            <a:srgbClr val="F5F3FA"/>
           </a:solidFill>
-          <a:ln w="9525">
+          <a:ln w="15240">
             <a:solidFill>
-              <a:srgbClr val="D9E2EE"/>
+              <a:srgbClr val="DCD4EE"/>
             </a:solidFill>
           </a:ln>
           <a:effectLst>
@@ -16626,11 +16556,11 @@
             </a:avLst>
           </a:prstGeom>
           <a:solidFill>
-            <a:srgbClr val="F7FAFD"/>
+            <a:srgbClr val="EEF7F2"/>
           </a:solidFill>
-          <a:ln w="9525">
+          <a:ln w="15240">
             <a:solidFill>
-              <a:srgbClr val="D9E2EE"/>
+              <a:srgbClr val="C6E4D2"/>
             </a:solidFill>
           </a:ln>
           <a:effectLst>
@@ -17158,10 +17088,12 @@
             </a:avLst>
           </a:prstGeom>
           <a:solidFill>
-            <a:srgbClr val="1E4A7E"/>
+            <a:srgbClr val="F6F9FC"/>
           </a:solidFill>
-          <a:ln>
-            <a:noFill/>
+          <a:ln w="12700">
+            <a:solidFill>
+              <a:srgbClr val="DAE3EE"/>
+            </a:solidFill>
           </a:ln>
         </p:spPr>
         <p:txBody>
@@ -17206,7 +17138,7 @@
             <a:r>
               <a:rPr sz="1350" b="1" i="0" lang="en-US">
                 <a:solidFill>
-                  <a:srgbClr val="F08418"/>
+                  <a:srgbClr val="0F2240"/>
                 </a:solidFill>
                 <a:latin typeface="Calibri"/>
               </a:rPr>
@@ -17249,7 +17181,7 @@
             <a:r>
               <a:rPr sz="780" b="0" i="0" lang="en-US">
                 <a:solidFill>
-                  <a:srgbClr val="B9C7DE"/>
+                  <a:srgbClr val="475569"/>
                 </a:solidFill>
                 <a:latin typeface="Calibri"/>
               </a:rPr>
@@ -17435,10 +17367,12 @@
             </a:avLst>
           </a:prstGeom>
           <a:solidFill>
-            <a:srgbClr val="1E4A7E"/>
+            <a:srgbClr val="F6F9FC"/>
           </a:solidFill>
-          <a:ln>
-            <a:noFill/>
+          <a:ln w="12700">
+            <a:solidFill>
+              <a:srgbClr val="DAE3EE"/>
+            </a:solidFill>
           </a:ln>
         </p:spPr>
         <p:txBody>
@@ -17483,7 +17417,7 @@
             <a:r>
               <a:rPr sz="1350" b="1" i="0" lang="en-US">
                 <a:solidFill>
-                  <a:srgbClr val="F08418"/>
+                  <a:srgbClr val="0F2240"/>
                 </a:solidFill>
                 <a:latin typeface="Calibri"/>
               </a:rPr>
@@ -17526,7 +17460,7 @@
             <a:r>
               <a:rPr sz="780" b="0" i="0" lang="en-US">
                 <a:solidFill>
-                  <a:srgbClr val="B9C7DE"/>
+                  <a:srgbClr val="475569"/>
                 </a:solidFill>
                 <a:latin typeface="Calibri"/>
               </a:rPr>
@@ -17712,10 +17646,12 @@
             </a:avLst>
           </a:prstGeom>
           <a:solidFill>
-            <a:srgbClr val="1E4A7E"/>
+            <a:srgbClr val="F6F9FC"/>
           </a:solidFill>
-          <a:ln>
-            <a:noFill/>
+          <a:ln w="12700">
+            <a:solidFill>
+              <a:srgbClr val="DAE3EE"/>
+            </a:solidFill>
           </a:ln>
         </p:spPr>
         <p:txBody>
@@ -17760,7 +17696,7 @@
             <a:r>
               <a:rPr sz="1350" b="1" i="0" lang="en-US">
                 <a:solidFill>
-                  <a:srgbClr val="F08418"/>
+                  <a:srgbClr val="0F2240"/>
                 </a:solidFill>
                 <a:latin typeface="Calibri"/>
               </a:rPr>
@@ -17803,7 +17739,7 @@
             <a:r>
               <a:rPr sz="780" b="0" i="0" lang="en-US">
                 <a:solidFill>
-                  <a:srgbClr val="B9C7DE"/>
+                  <a:srgbClr val="475569"/>
                 </a:solidFill>
                 <a:latin typeface="Calibri"/>
               </a:rPr>
@@ -17989,10 +17925,12 @@
             </a:avLst>
           </a:prstGeom>
           <a:solidFill>
-            <a:srgbClr val="1E4A7E"/>
+            <a:srgbClr val="F6F9FC"/>
           </a:solidFill>
-          <a:ln>
-            <a:noFill/>
+          <a:ln w="12700">
+            <a:solidFill>
+              <a:srgbClr val="DAE3EE"/>
+            </a:solidFill>
           </a:ln>
         </p:spPr>
         <p:txBody>
@@ -18037,7 +17975,7 @@
             <a:r>
               <a:rPr sz="1350" b="1" i="0" lang="en-US">
                 <a:solidFill>
-                  <a:srgbClr val="F08418"/>
+                  <a:srgbClr val="0F2240"/>
                 </a:solidFill>
                 <a:latin typeface="Calibri"/>
               </a:rPr>
@@ -18080,7 +18018,7 @@
             <a:r>
               <a:rPr sz="780" b="0" i="0" lang="en-US">
                 <a:solidFill>
-                  <a:srgbClr val="B9C7DE"/>
+                  <a:srgbClr val="475569"/>
                 </a:solidFill>
                 <a:latin typeface="Calibri"/>
               </a:rPr>
@@ -18266,10 +18204,12 @@
             </a:avLst>
           </a:prstGeom>
           <a:solidFill>
-            <a:srgbClr val="1E4A7E"/>
+            <a:srgbClr val="F6F9FC"/>
           </a:solidFill>
-          <a:ln>
-            <a:noFill/>
+          <a:ln w="12700">
+            <a:solidFill>
+              <a:srgbClr val="DAE3EE"/>
+            </a:solidFill>
           </a:ln>
         </p:spPr>
         <p:txBody>
@@ -18314,7 +18254,7 @@
             <a:r>
               <a:rPr sz="1350" b="1" i="0" lang="en-US">
                 <a:solidFill>
-                  <a:srgbClr val="FFB35C"/>
+                  <a:srgbClr val="0F2240"/>
                 </a:solidFill>
                 <a:latin typeface="Calibri"/>
               </a:rPr>
@@ -18357,7 +18297,7 @@
             <a:r>
               <a:rPr sz="780" b="0" i="0" lang="en-US">
                 <a:solidFill>
-                  <a:srgbClr val="B9C7DE"/>
+                  <a:srgbClr val="475569"/>
                 </a:solidFill>
                 <a:latin typeface="Calibri"/>
               </a:rPr>
@@ -18771,11 +18711,11 @@
             </a:avLst>
           </a:prstGeom>
           <a:solidFill>
-            <a:srgbClr val="F7FAFD"/>
+            <a:srgbClr val="F6F9FC"/>
           </a:solidFill>
-          <a:ln w="9525">
+          <a:ln w="15240">
             <a:solidFill>
-              <a:srgbClr val="D9E2EE"/>
+              <a:srgbClr val="DAE3EE"/>
             </a:solidFill>
           </a:ln>
           <a:effectLst>
@@ -18887,9 +18827,9 @@
           <a:solidFill>
             <a:srgbClr val="FFFFFF"/>
           </a:solidFill>
-          <a:ln w="9525">
+          <a:ln w="12700">
             <a:solidFill>
-              <a:srgbClr val="D9E2EE"/>
+              <a:srgbClr val="DAE3EE"/>
             </a:solidFill>
           </a:ln>
           <a:effectLst>
@@ -18942,7 +18882,7 @@
             <a:r>
               <a:rPr sz="1300" b="1" i="0" lang="en-US">
                 <a:solidFill>
-                  <a:srgbClr val="D9700F"/>
+                  <a:srgbClr val="0E7490"/>
                 </a:solidFill>
                 <a:latin typeface="Consolas"/>
               </a:rPr>
@@ -18983,11 +18923,10 @@
               <a:buNone/>
             </a:pPr>
             <a:r>
-              <a:rPr sz="969" b="1" i="0" lang="en-US">
-                <a:solidFill>
-                  <a:srgbClr val="14345C"/>
-                </a:solidFill>
-                <a:latin typeface="Calibri"/>
+              <a:rPr b="1" sz="850">
+                <a:solidFill>
+                  <a:srgbClr val="0F2240"/>
+                </a:solidFill>
               </a:rPr>
               <a:t>Liu et al. (IEEE ICSOS, 2025)</a:t>
             </a:r>
@@ -19026,42 +18965,29 @@
               <a:buNone/>
             </a:pPr>
             <a:r>
-              <a:rPr sz="840" b="0" i="1" lang="en-US">
-                <a:solidFill>
-                  <a:srgbClr val="566074"/>
-                </a:solidFill>
-                <a:latin typeface="Calibri"/>
-              </a:rPr>
-              <a:t>'Pointing, Acquisition, and Tracking (PAT) for Optical Satellite Communications: The ALIGN UK Mission'</a:t>
-            </a:r>
-          </a:p>
-          <a:p>
-            <a:pPr algn="l" marL="0" indent="0">
-              <a:spcBef>
-                <a:spcPts val="0"/>
-              </a:spcBef>
-              <a:spcAft>
-                <a:spcPts val="0"/>
-              </a:spcAft>
-              <a:buNone/>
-            </a:pPr>
-            <a:r>
-              <a:rPr sz="840" b="0" i="0" lang="en-US">
-                <a:solidFill>
-                  <a:srgbClr val="1E2638"/>
-                </a:solidFill>
-                <a:latin typeface="Calibri"/>
-              </a:rPr>
-              <a:t>Satellite PAT handover: establishes coarse-to-fine transition dynamics and ≤ 2 s acquisition SLA.</a:t>
-            </a:r>
-            <a:r>
-              <a:rPr sz="760" b="0" i="0" lang="en-US">
-                <a:solidFill>
-                  <a:srgbClr val="8C97A8"/>
-                </a:solidFill>
-                <a:latin typeface="Calibri"/>
-              </a:rPr>
-              <a:t>  DOI: 10.1109/icsos66026.2025.11443125</a:t>
+              <a:rPr sz="750">
+                <a:solidFill>
+                  <a:srgbClr val="212B36"/>
+                </a:solidFill>
+              </a:rPr>
+              <a:t>'Pointing, Acquisition, and Tracking (PAT) for Optical Satellite Communications: The ALIGN UK Mission' — Satellite PAT handover: establishes coarse-to-fine transition dynamics and ≤ 2 s acquisition SLA. </a:t>
+            </a:r>
+            <a:r>
+              <a:rPr b="1" sz="750">
+                <a:solidFill>
+                  <a:srgbClr val="0E7490"/>
+                </a:solidFill>
+              </a:rPr>
+              <a:t>DOI: </a:t>
+            </a:r>
+            <a:r>
+              <a:rPr sz="750" u="sng">
+                <a:solidFill>
+                  <a:srgbClr val="0D6EFD"/>
+                </a:solidFill>
+                <a:hlinkClick r:id="rId6"/>
+              </a:rPr>
+              <a:t>10.1109/icsos66026.2025.11443125</a:t>
             </a:r>
           </a:p>
         </p:txBody>
@@ -19085,9 +19011,9 @@
           <a:solidFill>
             <a:srgbClr val="FFFFFF"/>
           </a:solidFill>
-          <a:ln w="9525">
+          <a:ln w="12700">
             <a:solidFill>
-              <a:srgbClr val="D9E2EE"/>
+              <a:srgbClr val="DAE3EE"/>
             </a:solidFill>
           </a:ln>
           <a:effectLst>
@@ -19140,7 +19066,7 @@
             <a:r>
               <a:rPr sz="1300" b="1" i="0" lang="en-US">
                 <a:solidFill>
-                  <a:srgbClr val="D9700F"/>
+                  <a:srgbClr val="0E7490"/>
                 </a:solidFill>
                 <a:latin typeface="Consolas"/>
               </a:rPr>
@@ -19181,11 +19107,10 @@
               <a:buNone/>
             </a:pPr>
             <a:r>
-              <a:rPr sz="969" b="1" i="0" lang="en-US">
-                <a:solidFill>
-                  <a:srgbClr val="14345C"/>
-                </a:solidFill>
-                <a:latin typeface="Calibri"/>
+              <a:rPr b="1" sz="850">
+                <a:solidFill>
+                  <a:srgbClr val="0F2240"/>
+                </a:solidFill>
               </a:rPr>
               <a:t>Sun, Wang, Wu &amp; Liu (MDPI Photonics, 2024)</a:t>
             </a:r>
@@ -19224,42 +19149,29 @@
               <a:buNone/>
             </a:pPr>
             <a:r>
-              <a:rPr sz="840" b="0" i="1" lang="en-US">
-                <a:solidFill>
-                  <a:srgbClr val="566074"/>
-                </a:solidFill>
-                <a:latin typeface="Calibri"/>
-              </a:rPr>
-              <a:t>'High-Precision Tracking of Free-Space Optical Communication System on Mobile Platforms'</a:t>
-            </a:r>
-          </a:p>
-          <a:p>
-            <a:pPr algn="l" marL="0" indent="0">
-              <a:spcBef>
-                <a:spcPts val="0"/>
-              </a:spcBef>
-              <a:spcAft>
-                <a:spcPts val="0"/>
-              </a:spcAft>
-              <a:buNone/>
-            </a:pPr>
-            <a:r>
-              <a:rPr sz="840" b="0" i="0" lang="en-US">
-                <a:solidFill>
-                  <a:srgbClr val="1E2638"/>
-                </a:solidFill>
-                <a:latin typeface="Calibri"/>
-              </a:rPr>
-              <a:t>Mobile platform dynamics: validates multi-axis platform jitter rejection (±20 px/frame).</a:t>
-            </a:r>
-            <a:r>
-              <a:rPr sz="760" b="0" i="0" lang="en-US">
-                <a:solidFill>
-                  <a:srgbClr val="8C97A8"/>
-                </a:solidFill>
-                <a:latin typeface="Calibri"/>
-              </a:rPr>
-              <a:t>  DOI: 10.3390/photonics11100900</a:t>
+              <a:rPr sz="750">
+                <a:solidFill>
+                  <a:srgbClr val="212B36"/>
+                </a:solidFill>
+              </a:rPr>
+              <a:t>'High-Precision Tracking of Free-Space Optical Communication System on Mobile Platforms' — Mobile platform dynamics: validates multi-axis platform jitter rejection (±20 px/frame). </a:t>
+            </a:r>
+            <a:r>
+              <a:rPr b="1" sz="750">
+                <a:solidFill>
+                  <a:srgbClr val="0E7490"/>
+                </a:solidFill>
+              </a:rPr>
+              <a:t>DOI: </a:t>
+            </a:r>
+            <a:r>
+              <a:rPr sz="750" u="sng">
+                <a:solidFill>
+                  <a:srgbClr val="0D6EFD"/>
+                </a:solidFill>
+                <a:hlinkClick r:id="rId7"/>
+              </a:rPr>
+              <a:t>10.3390/photonics11100900</a:t>
             </a:r>
           </a:p>
         </p:txBody>
@@ -19283,9 +19195,9 @@
           <a:solidFill>
             <a:srgbClr val="FFFFFF"/>
           </a:solidFill>
-          <a:ln w="9525">
+          <a:ln w="12700">
             <a:solidFill>
-              <a:srgbClr val="D9E2EE"/>
+              <a:srgbClr val="DAE3EE"/>
             </a:solidFill>
           </a:ln>
           <a:effectLst>
@@ -19338,7 +19250,7 @@
             <a:r>
               <a:rPr sz="1300" b="1" i="0" lang="en-US">
                 <a:solidFill>
-                  <a:srgbClr val="D9700F"/>
+                  <a:srgbClr val="0E7490"/>
                 </a:solidFill>
                 <a:latin typeface="Consolas"/>
               </a:rPr>
@@ -19379,11 +19291,10 @@
               <a:buNone/>
             </a:pPr>
             <a:r>
-              <a:rPr sz="969" b="1" i="0" lang="en-US">
-                <a:solidFill>
-                  <a:srgbClr val="14345C"/>
-                </a:solidFill>
-                <a:latin typeface="Calibri"/>
+              <a:rPr b="1" sz="850">
+                <a:solidFill>
+                  <a:srgbClr val="0F2240"/>
+                </a:solidFill>
               </a:rPr>
               <a:t>Saha, Qin, Li, Ye &amp; Jayasuriya (IEEE/CVF CVPR, 2024)</a:t>
             </a:r>
@@ -19422,42 +19333,29 @@
               <a:buNone/>
             </a:pPr>
             <a:r>
-              <a:rPr sz="840" b="0" i="1" lang="en-US">
-                <a:solidFill>
-                  <a:srgbClr val="566074"/>
-                </a:solidFill>
-                <a:latin typeface="Calibri"/>
-              </a:rPr>
-              <a:t>'Turb-Seg-Res: A Segment-then-Restore Pipeline for Dynamic Videos with Atmospheric Turbulence'</a:t>
-            </a:r>
-          </a:p>
-          <a:p>
-            <a:pPr algn="l" marL="0" indent="0">
-              <a:spcBef>
-                <a:spcPts val="0"/>
-              </a:spcBef>
-              <a:spcAft>
-                <a:spcPts val="0"/>
-              </a:spcAft>
-              <a:buNone/>
-            </a:pPr>
-            <a:r>
-              <a:rPr sz="840" b="0" i="0" lang="en-US">
-                <a:solidFill>
-                  <a:srgbClr val="1E2638"/>
-                </a:solidFill>
-                <a:latin typeface="Calibri"/>
-              </a:rPr>
-              <a:t>Deep vision in turbulence: formulates spatio-temporal segmentation under refractive shimmer.</a:t>
-            </a:r>
-            <a:r>
-              <a:rPr sz="760" b="0" i="0" lang="en-US">
-                <a:solidFill>
-                  <a:srgbClr val="8C97A8"/>
-                </a:solidFill>
-                <a:latin typeface="Calibri"/>
-              </a:rPr>
-              <a:t>  DOI: 10.1109/CVPR52733.2024.02389</a:t>
+              <a:rPr sz="750">
+                <a:solidFill>
+                  <a:srgbClr val="212B36"/>
+                </a:solidFill>
+              </a:rPr>
+              <a:t>'Turb-Seg-Res: A Segment-then-Restore Pipeline for Dynamic Videos with Atmospheric Turbulence' — Deep vision in turbulence: formulates spatio-temporal segmentation under refractive shimmer. </a:t>
+            </a:r>
+            <a:r>
+              <a:rPr b="1" sz="750">
+                <a:solidFill>
+                  <a:srgbClr val="0E7490"/>
+                </a:solidFill>
+              </a:rPr>
+              <a:t>DOI: </a:t>
+            </a:r>
+            <a:r>
+              <a:rPr sz="750" u="sng">
+                <a:solidFill>
+                  <a:srgbClr val="0D6EFD"/>
+                </a:solidFill>
+                <a:hlinkClick r:id="rId8"/>
+              </a:rPr>
+              <a:t>10.1109/CVPR52733.2024.02389</a:t>
             </a:r>
           </a:p>
         </p:txBody>
@@ -19481,9 +19379,9 @@
           <a:solidFill>
             <a:srgbClr val="FFFFFF"/>
           </a:solidFill>
-          <a:ln w="9525">
+          <a:ln w="12700">
             <a:solidFill>
-              <a:srgbClr val="D9E2EE"/>
+              <a:srgbClr val="DAE3EE"/>
             </a:solidFill>
           </a:ln>
           <a:effectLst>
@@ -19536,7 +19434,7 @@
             <a:r>
               <a:rPr sz="1300" b="1" i="0" lang="en-US">
                 <a:solidFill>
-                  <a:srgbClr val="D9700F"/>
+                  <a:srgbClr val="0E7490"/>
                 </a:solidFill>
                 <a:latin typeface="Consolas"/>
               </a:rPr>
@@ -19577,11 +19475,10 @@
               <a:buNone/>
             </a:pPr>
             <a:r>
-              <a:rPr sz="969" b="1" i="0" lang="en-US">
-                <a:solidFill>
-                  <a:srgbClr val="14345C"/>
-                </a:solidFill>
-                <a:latin typeface="Calibri"/>
+              <a:rPr b="1" sz="850">
+                <a:solidFill>
+                  <a:srgbClr val="0F2240"/>
+                </a:solidFill>
               </a:rPr>
               <a:t>Qin, Saha, Chung, Jayasuriya, Ye &amp; Li (ECCV, 2024)</a:t>
             </a:r>
@@ -19620,42 +19517,29 @@
               <a:buNone/>
             </a:pPr>
             <a:r>
-              <a:rPr sz="840" b="0" i="1" lang="en-US">
-                <a:solidFill>
-                  <a:srgbClr val="566074"/>
-                </a:solidFill>
-                <a:latin typeface="Calibri"/>
-              </a:rPr>
-              <a:t>'Unsupervised Moving Object Segmentation with Atmospheric Turbulence'</a:t>
-            </a:r>
-          </a:p>
-          <a:p>
-            <a:pPr algn="l" marL="0" indent="0">
-              <a:spcBef>
-                <a:spcPts val="0"/>
-              </a:spcBef>
-              <a:spcAft>
-                <a:spcPts val="0"/>
-              </a:spcAft>
-              <a:buNone/>
-            </a:pPr>
-            <a:r>
-              <a:rPr sz="840" b="0" i="0" lang="en-US">
-                <a:solidFill>
-                  <a:srgbClr val="1E2638"/>
-                </a:solidFill>
-                <a:latin typeface="Calibri"/>
-              </a:rPr>
-              <a:t>Deep saliency prior: separates faint moving beacons under dense haze, fog and scintillation.</a:t>
-            </a:r>
-            <a:r>
-              <a:rPr sz="760" b="0" i="0" lang="en-US">
-                <a:solidFill>
-                  <a:srgbClr val="8C97A8"/>
-                </a:solidFill>
-                <a:latin typeface="Calibri"/>
-              </a:rPr>
-              <a:t>  DOI: 10.1007/978-3-031-72658-3_2</a:t>
+              <a:rPr sz="750">
+                <a:solidFill>
+                  <a:srgbClr val="212B36"/>
+                </a:solidFill>
+              </a:rPr>
+              <a:t>'Unsupervised Moving Object Segmentation with Atmospheric Turbulence' — Deep saliency prior: separates faint moving beacons under dense haze, fog and scintillation. </a:t>
+            </a:r>
+            <a:r>
+              <a:rPr b="1" sz="750">
+                <a:solidFill>
+                  <a:srgbClr val="0E7490"/>
+                </a:solidFill>
+              </a:rPr>
+              <a:t>DOI: </a:t>
+            </a:r>
+            <a:r>
+              <a:rPr sz="750" u="sng">
+                <a:solidFill>
+                  <a:srgbClr val="0D6EFD"/>
+                </a:solidFill>
+                <a:hlinkClick r:id="rId9"/>
+              </a:rPr>
+              <a:t>10.1007/978-3-031-72658-3_2</a:t>
             </a:r>
           </a:p>
         </p:txBody>
@@ -19679,9 +19563,9 @@
           <a:solidFill>
             <a:srgbClr val="FFFFFF"/>
           </a:solidFill>
-          <a:ln w="9525">
+          <a:ln w="12700">
             <a:solidFill>
-              <a:srgbClr val="D9E2EE"/>
+              <a:srgbClr val="DAE3EE"/>
             </a:solidFill>
           </a:ln>
           <a:effectLst>
@@ -19734,7 +19618,7 @@
             <a:r>
               <a:rPr sz="1300" b="1" i="0" lang="en-US">
                 <a:solidFill>
-                  <a:srgbClr val="D9700F"/>
+                  <a:srgbClr val="0E7490"/>
                 </a:solidFill>
                 <a:latin typeface="Consolas"/>
               </a:rPr>
@@ -19775,11 +19659,10 @@
               <a:buNone/>
             </a:pPr>
             <a:r>
-              <a:rPr sz="969" b="1" i="0" lang="en-US">
-                <a:solidFill>
-                  <a:srgbClr val="14345C"/>
-                </a:solidFill>
-                <a:latin typeface="Calibri"/>
+              <a:rPr b="1" sz="850">
+                <a:solidFill>
+                  <a:srgbClr val="0F2240"/>
+                </a:solidFill>
               </a:rPr>
               <a:t>Yang, Xie, Liu, Mo &amp; Zeng (MDPI Remote Sensing, 2023)</a:t>
             </a:r>
@@ -19818,42 +19701,29 @@
               <a:buNone/>
             </a:pPr>
             <a:r>
-              <a:rPr sz="840" b="0" i="1" lang="en-US">
-                <a:solidFill>
-                  <a:srgbClr val="566074"/>
-                </a:solidFill>
-                <a:latin typeface="Calibri"/>
-              </a:rPr>
-              <a:t>'Centroid Extraction of Laser Spots Captured by Infrared Detectors Combining Observation Data'</a:t>
-            </a:r>
-          </a:p>
-          <a:p>
-            <a:pPr algn="l" marL="0" indent="0">
-              <a:spcBef>
-                <a:spcPts val="0"/>
-              </a:spcBef>
-              <a:spcAft>
-                <a:spcPts val="0"/>
-              </a:spcAft>
-              <a:buNone/>
-            </a:pPr>
-            <a:r>
-              <a:rPr sz="840" b="0" i="0" lang="en-US">
-                <a:solidFill>
-                  <a:srgbClr val="1E2638"/>
-                </a:solidFill>
-                <a:latin typeface="Calibri"/>
-              </a:rPr>
-              <a:t>Sub-pixel Gaussian diffusion: mathematical proof of &lt; 0.2 px centroid accuracy under noise.</a:t>
-            </a:r>
-            <a:r>
-              <a:rPr sz="760" b="0" i="0" lang="en-US">
-                <a:solidFill>
-                  <a:srgbClr val="8C97A8"/>
-                </a:solidFill>
-                <a:latin typeface="Calibri"/>
-              </a:rPr>
-              <a:t>  DOI: 10.3390/rs15082129</a:t>
+              <a:rPr sz="750">
+                <a:solidFill>
+                  <a:srgbClr val="212B36"/>
+                </a:solidFill>
+              </a:rPr>
+              <a:t>'Centroid Extraction of Laser Spots Captured by Infrared Detectors Combining Observation Data' — Sub-pixel Gaussian diffusion: mathematical proof of &lt; 0.2 px centroid accuracy under noise. </a:t>
+            </a:r>
+            <a:r>
+              <a:rPr b="1" sz="750">
+                <a:solidFill>
+                  <a:srgbClr val="0E7490"/>
+                </a:solidFill>
+              </a:rPr>
+              <a:t>DOI: </a:t>
+            </a:r>
+            <a:r>
+              <a:rPr sz="750" u="sng">
+                <a:solidFill>
+                  <a:srgbClr val="0D6EFD"/>
+                </a:solidFill>
+                <a:hlinkClick r:id="rId10"/>
+              </a:rPr>
+              <a:t>10.3390/rs15082129</a:t>
             </a:r>
           </a:p>
         </p:txBody>
@@ -19877,9 +19747,9 @@
           <a:solidFill>
             <a:srgbClr val="FFFFFF"/>
           </a:solidFill>
-          <a:ln w="9525">
+          <a:ln w="12700">
             <a:solidFill>
-              <a:srgbClr val="D9E2EE"/>
+              <a:srgbClr val="DAE3EE"/>
             </a:solidFill>
           </a:ln>
           <a:effectLst>
@@ -19932,7 +19802,7 @@
             <a:r>
               <a:rPr sz="1300" b="1" i="0" lang="en-US">
                 <a:solidFill>
-                  <a:srgbClr val="D9700F"/>
+                  <a:srgbClr val="0E7490"/>
                 </a:solidFill>
                 <a:latin typeface="Consolas"/>
               </a:rPr>
@@ -19973,13 +19843,12 @@
               <a:buNone/>
             </a:pPr>
             <a:r>
-              <a:rPr sz="969" b="1" i="0" lang="en-US">
-                <a:solidFill>
-                  <a:srgbClr val="14345C"/>
-                </a:solidFill>
-                <a:latin typeface="Calibri"/>
-              </a:rPr>
-              <a:t>Kaushal &amp; Kaddoum (IEEE COMST, 2016)</a:t>
+              <a:rPr b="1" sz="850">
+                <a:solidFill>
+                  <a:srgbClr val="0F2240"/>
+                </a:solidFill>
+              </a:rPr>
+              <a:t>Kaushal &amp; Kaddoum (IEEE COMST, 2017)</a:t>
             </a:r>
           </a:p>
         </p:txBody>
@@ -20016,42 +19885,29 @@
               <a:buNone/>
             </a:pPr>
             <a:r>
-              <a:rPr sz="840" b="0" i="1" lang="en-US">
-                <a:solidFill>
-                  <a:srgbClr val="566074"/>
-                </a:solidFill>
-                <a:latin typeface="Calibri"/>
-              </a:rPr>
-              <a:t>'Free Space Optical Communication: Challenges and Mitigation Techniques'</a:t>
-            </a:r>
-          </a:p>
-          <a:p>
-            <a:pPr algn="l" marL="0" indent="0">
-              <a:spcBef>
-                <a:spcPts val="0"/>
-              </a:spcBef>
-              <a:spcAft>
-                <a:spcPts val="0"/>
-              </a:spcAft>
-              <a:buNone/>
-            </a:pPr>
-            <a:r>
-              <a:rPr sz="840" b="0" i="0" lang="en-US">
-                <a:solidFill>
-                  <a:srgbClr val="1E2638"/>
-                </a:solidFill>
-                <a:latin typeface="Calibri"/>
-              </a:rPr>
-              <a:t>Foundational FSOC survey: gold-standard reference for Beer-Lambert &amp; Gamma-Gamma channels.</a:t>
-            </a:r>
-            <a:r>
-              <a:rPr sz="760" b="0" i="0" lang="en-US">
-                <a:solidFill>
-                  <a:srgbClr val="8C97A8"/>
-                </a:solidFill>
-                <a:latin typeface="Calibri"/>
-              </a:rPr>
-              <a:t>  DOI: 10.1109/COMST.2016.2617691</a:t>
+              <a:rPr sz="750">
+                <a:solidFill>
+                  <a:srgbClr val="212B36"/>
+                </a:solidFill>
+              </a:rPr>
+              <a:t>'Optical Communication in Space: Challenges and Mitigation Techniques' — Foundational survey: gold-standard reference for Beer-Lambert extinction &amp; scintillation channels. </a:t>
+            </a:r>
+            <a:r>
+              <a:rPr b="1" sz="750">
+                <a:solidFill>
+                  <a:srgbClr val="0E7490"/>
+                </a:solidFill>
+              </a:rPr>
+              <a:t>DOI: </a:t>
+            </a:r>
+            <a:r>
+              <a:rPr sz="750" u="sng">
+                <a:solidFill>
+                  <a:srgbClr val="0D6EFD"/>
+                </a:solidFill>
+                <a:hlinkClick r:id="rId11"/>
+              </a:rPr>
+              <a:t>10.1109/COMST.2016.2603518</a:t>
             </a:r>
           </a:p>
         </p:txBody>
@@ -20073,11 +19929,11 @@
             </a:avLst>
           </a:prstGeom>
           <a:solidFill>
-            <a:srgbClr val="F7FAFD"/>
+            <a:srgbClr val="F6F9FC"/>
           </a:solidFill>
-          <a:ln w="9525">
+          <a:ln w="15240">
             <a:solidFill>
-              <a:srgbClr val="D9E2EE"/>
+              <a:srgbClr val="DAE3EE"/>
             </a:solidFill>
           </a:ln>
           <a:effectLst>
@@ -20254,11 +20110,11 @@
             </a:avLst>
           </a:prstGeom>
           <a:solidFill>
-            <a:srgbClr val="FFFFFF"/>
+            <a:srgbClr val="EBF4FC"/>
           </a:solidFill>
-          <a:ln w="9525">
+          <a:ln w="12700">
             <a:solidFill>
-              <a:srgbClr val="D9E2EE"/>
+              <a:srgbClr val="C5DEF5"/>
             </a:solidFill>
           </a:ln>
         </p:spPr>
@@ -20304,7 +20160,7 @@
             <a:r>
               <a:rPr sz="840" b="0" i="0" lang="en-US">
                 <a:solidFill>
-                  <a:srgbClr val="14345C"/>
+                  <a:srgbClr val="0E7490"/>
                 </a:solidFill>
                 <a:latin typeface="Consolas"/>
               </a:rPr>
@@ -20405,40 +20261,46 @@
                 <a:spcPts val="0"/>
               </a:spcBef>
               <a:spcAft>
-                <a:spcPts val="0"/>
-              </a:spcAft>
-              <a:buNone/>
-              <a:defRPr sz="800">
-                <a:solidFill>
-                  <a:srgbClr val="3C3C3C"/>
-                </a:solidFill>
-              </a:defRPr>
-            </a:pPr>
-            <a:r>
+                <a:spcPts val="100"/>
+              </a:spcAft>
+              <a:buNone/>
+            </a:pPr>
+            <a:r>
+              <a:rPr sz="800">
+                <a:solidFill>
+                  <a:srgbClr val="212B36"/>
+                </a:solidFill>
+              </a:rPr>
               <a:t>1. docs/system_architecture_plan.md (System Blueprint)</a:t>
             </a:r>
           </a:p>
           <a:p>
             <a:pPr>
-              <a:defRPr sz="800">
-                <a:solidFill>
-                  <a:srgbClr val="3C3C3C"/>
-                </a:solidFill>
-              </a:defRPr>
-            </a:pPr>
-            <a:r>
+              <a:spcAft>
+                <a:spcPts val="100"/>
+              </a:spcAft>
+            </a:pPr>
+            <a:r>
+              <a:rPr sz="800">
+                <a:solidFill>
+                  <a:srgbClr val="212B36"/>
+                </a:solidFill>
+              </a:rPr>
               <a:t>2. academic_research/ (Literature Review &amp; Papers)</a:t>
             </a:r>
           </a:p>
           <a:p>
             <a:pPr>
-              <a:defRPr sz="800">
-                <a:solidFill>
-                  <a:srgbClr val="3C3C3C"/>
-                </a:solidFill>
-              </a:defRPr>
-            </a:pPr>
-            <a:r>
+              <a:spcAft>
+                <a:spcPts val="100"/>
+              </a:spcAft>
+            </a:pPr>
+            <a:r>
+              <a:rPr sz="800">
+                <a:solidFill>
+                  <a:srgbClr val="212B36"/>
+                </a:solidFill>
+              </a:rPr>
               <a:t>3. distributed_demo/ (3-Node Networked Simulation)</a:t>
             </a:r>
           </a:p>
@@ -20469,7 +20331,7 @@
             <a:pPr>
               <a:defRPr sz="950" b="1">
                 <a:solidFill>
-                  <a:srgbClr val="0073E6"/>
+                  <a:srgbClr val="0E7490"/>
                 </a:solidFill>
               </a:defRPr>
             </a:pPr>
@@ -20488,7 +20350,7 @@
           <p:nvPr/>
         </p:nvPicPr>
         <p:blipFill>
-          <a:blip r:embed="rId6"/>
+          <a:blip r:embed="rId12"/>
           <a:stretch>
             <a:fillRect/>
           </a:stretch>

</xml_diff>